<commit_message>
Peisistratos: stummes Schaubild als A5-Blatt für den Hefter; Folien 11–12 und Handreichung angepasst
Co-Authored-By: Claude Opus 5.5 <noreply@anthropic.com>
Claude-Session: https://claude.ai/code/session_013iN4Tiarea1J9YUJHZ9iqC
</commit_message>
<xml_diff>
--- a/Geschichte_11/Stunde_Peisistratos/Folien_Peisistratos.pptx
+++ b/Geschichte_11/Stunde_Peisistratos/Folien_Peisistratos.pptx
@@ -691,7 +691,7 @@
           <a:p>
             <a:r>
               <a:rPr lang="en-US" dirty="0"/>
-              <a:t>32–40 Min. Leeres Gerüst an die Tafel zeichnen (Mitte, vier Felder, Pfeile hin und zurück) – Skizze in der Handreichung. Gemeinsam füllen, Fragen klären. Danach in den Hefter.</a:t>
+              <a:t>32–40 Min. Blatt „Stummes Schaubild“ austeilen. Dasselbe Gerüst an die Tafel zeichnen (Skizze in der Handreichung) und gemeinsam füllen – jeder schreibt auf seinem Blatt mit. Fragen dabei klären. Blatt in den Hefter.</a:t>
             </a:r>
             <a:endParaRPr lang="en-US" dirty="0"/>
           </a:p>
@@ -3093,7 +3093,7 @@
                 <a:ea typeface="Calibri" pitchFamily="34" charset="-122"/>
                 <a:cs typeface="Calibri" pitchFamily="34" charset="-120"/>
               </a:rPr>
-              <a:t>SICHERUNG · TAFEL · HEFTER</a:t>
+              <a:t>SICHERUNG · BLATT · TAFEL</a:t>
             </a:r>
             <a:endParaRPr lang="en-US" sz="1100" dirty="0"/>
           </a:p>
@@ -3313,7 +3313,7 @@
               <a:buNone/>
             </a:pPr>
             <a:r>
-              <a:rPr lang="en-US" sz="1350" dirty="0">
+              <a:rPr lang="en-US" sz="1300" dirty="0">
                 <a:solidFill>
                   <a:srgbClr val="2B2318"/>
                 </a:solidFill>
@@ -3321,9 +3321,9 @@
                 <a:ea typeface="Calibri" pitchFamily="34" charset="-122"/>
                 <a:cs typeface="Calibri" pitchFamily="34" charset="-120"/>
               </a:rPr>
-              <a:t>Was steht in der Mitte? Welche vier Gruppen stehen in den Feldern?</a:t>
-            </a:r>
-            <a:endParaRPr lang="en-US" sz="1350" dirty="0"/>
+              <a:t>Trage in die Mitte und in die vier Felder ein, wer gemeint ist.</a:t>
+            </a:r>
+            <a:endParaRPr lang="en-US" sz="1300" dirty="0"/>
           </a:p>
         </p:txBody>
       </p:sp>
@@ -3393,7 +3393,7 @@
               <a:buNone/>
             </a:pPr>
             <a:r>
-              <a:rPr lang="en-US" sz="1350" dirty="0">
+              <a:rPr lang="en-US" sz="1300" dirty="0">
                 <a:solidFill>
                   <a:srgbClr val="2B2318"/>
                 </a:solidFill>
@@ -3401,9 +3401,9 @@
                 <a:ea typeface="Calibri" pitchFamily="34" charset="-122"/>
                 <a:cs typeface="Calibri" pitchFamily="34" charset="-120"/>
               </a:rPr>
-              <a:t>Ordnet jedem Feld mindestens eine Maßnahme zu.</a:t>
-            </a:r>
-            <a:endParaRPr lang="en-US" sz="1350" dirty="0"/>
+              <a:t>Schreibe in jedes Feld mindestens eine Maßnahme. Beim Adel: ✓ wer gewinnt, ✗ wer verliert.</a:t>
+            </a:r>
+            <a:endParaRPr lang="en-US" sz="1300" dirty="0"/>
           </a:p>
         </p:txBody>
       </p:sp>
@@ -3473,7 +3473,7 @@
               <a:buNone/>
             </a:pPr>
             <a:r>
-              <a:rPr lang="en-US" sz="1350" dirty="0">
+              <a:rPr lang="en-US" sz="1300" dirty="0">
                 <a:solidFill>
                   <a:srgbClr val="2B2318"/>
                 </a:solidFill>
@@ -3481,9 +3481,9 @@
                 <a:ea typeface="Calibri" pitchFamily="34" charset="-122"/>
                 <a:cs typeface="Calibri" pitchFamily="34" charset="-120"/>
               </a:rPr>
-              <a:t>Was bedeuten die schwarzen und die goldenen Pfeile?</a:t>
-            </a:r>
-            <a:endParaRPr lang="en-US" sz="1350" dirty="0"/>
+              <a:t>Was bedeuten die dunklen, was die hellen Pfeile?</a:t>
+            </a:r>
+            <a:endParaRPr lang="en-US" sz="1300" dirty="0"/>
           </a:p>
         </p:txBody>
       </p:sp>
@@ -3553,7 +3553,7 @@
               <a:buNone/>
             </a:pPr>
             <a:r>
-              <a:rPr lang="en-US" sz="1350" dirty="0">
+              <a:rPr lang="en-US" sz="1300" dirty="0">
                 <a:solidFill>
                   <a:srgbClr val="2B2318"/>
                 </a:solidFill>
@@ -3561,9 +3561,9 @@
                 <a:ea typeface="Calibri" pitchFamily="34" charset="-122"/>
                 <a:cs typeface="Calibri" pitchFamily="34" charset="-120"/>
               </a:rPr>
-              <a:t>Übertragt das fertige Bild in den Hefter.</a:t>
-            </a:r>
-            <a:endParaRPr lang="en-US" sz="1350" dirty="0"/>
+              <a:t>Ergänze den Merksatz: „Peisistratos sichert seine Macht durch …“</a:t>
+            </a:r>
+            <a:endParaRPr lang="en-US" sz="1300" dirty="0"/>
           </a:p>
         </p:txBody>
       </p:sp>
@@ -3782,7 +3782,7 @@
                 <a:ea typeface="Cambria" pitchFamily="34" charset="-122"/>
                 <a:cs typeface="Cambria" pitchFamily="34" charset="-120"/>
               </a:rPr>
-              <a:t>Vergleicht mit eurem Hefter</a:t>
+              <a:t>Vergleicht mit eurem Blatt</a:t>
             </a:r>
             <a:endParaRPr lang="en-US" sz="2800" dirty="0"/>
           </a:p>

</xml_diff>

<commit_message>
Peisistratos: A4-Arbeitsblatt mit Teil A (Text, Personenkarte) und Teil B (Schaubild); Folien und Handreichung angepasst
Co-Authored-By: Claude Opus 5.5 <noreply@anthropic.com>
Claude-Session: https://claude.ai/code/session_013iN4Tiarea1J9YUJHZ9iqC
</commit_message>
<xml_diff>
--- a/Geschichte_11/Stunde_Peisistratos/Folien_Peisistratos.pptx
+++ b/Geschichte_11/Stunde_Peisistratos/Folien_Peisistratos.pptx
@@ -691,7 +691,7 @@
           <a:p>
             <a:r>
               <a:rPr lang="en-US" dirty="0"/>
-              <a:t>32–40 Min. Blatt „Stummes Schaubild“ austeilen. Dasselbe Gerüst an die Tafel zeichnen (Skizze in der Handreichung) und gemeinsam füllen – jeder schreibt auf seinem Blatt mit. Fragen dabei klären. Blatt in den Hefter.</a:t>
+              <a:t>32–40 Min. Karten an der Tafel abdecken oder abnehmen. Dasselbe Gerüst an die Tafel zeichnen (Skizze in der Handreichung) und gemeinsam füllen – jeder schreibt auf seinem Blatt (Teil B) mit. Fragen dabei klären. Blatt in den Hefter.</a:t>
             </a:r>
             <a:endParaRPr lang="en-US" dirty="0"/>
           </a:p>
@@ -1395,7 +1395,7 @@
           <a:p>
             <a:r>
               <a:rPr lang="en-US" dirty="0"/>
-              <a:t>9–18 Min. Herumgehen, zuhören. Hilfsimpulse gestuft: 1. Was ist das Problem? 2. Welches Stichwort sucht ihr im Text (Land, Geld, Aufträge, Feste …)? 3. Lest den Satz mit … (siehe Handreichung). Karte 9 (Alkmeonide) ist der einzige Verlierer – das Paar darf ruhig stutzen.</a:t>
+              <a:t>9–18 Min. Arbeitsblatt austeilen (je eins pro Schüler). Herumgehen, zuhören. Hilfsimpulse gestuft: 1. Was ist das Problem? 2. Welches Stichwort sucht ihr im Text (Land, Geld, Aufträge, Feste …)? 3. Lest den Satz mit … (siehe Handreichung). Karte 9 (Alkmeonide) ist der einzige Verlierer – das Paar darf ruhig stutzen.</a:t>
             </a:r>
             <a:endParaRPr lang="en-US" dirty="0"/>
           </a:p>
@@ -3093,7 +3093,7 @@
                 <a:ea typeface="Calibri" pitchFamily="34" charset="-122"/>
                 <a:cs typeface="Calibri" pitchFamily="34" charset="-120"/>
               </a:rPr>
-              <a:t>SICHERUNG · BLATT · TAFEL</a:t>
+              <a:t>SICHERUNG · BLATT TEIL B · TAFEL</a:t>
             </a:r>
             <a:endParaRPr lang="en-US" sz="1100" dirty="0"/>
           </a:p>
@@ -3132,7 +3132,7 @@
                 <a:ea typeface="Cambria" pitchFamily="34" charset="-122"/>
                 <a:cs typeface="Cambria" pitchFamily="34" charset="-120"/>
               </a:rPr>
-              <a:t>Das Bild aus dem Gedächtnis</a:t>
+              <a:t>Das ganze Bild auf euer Blatt</a:t>
             </a:r>
             <a:endParaRPr lang="en-US" sz="2800" dirty="0"/>
           </a:p>
@@ -3241,7 +3241,7 @@
                 <a:ea typeface="Calibri" pitchFamily="34" charset="-122"/>
                 <a:cs typeface="Calibri" pitchFamily="34" charset="-120"/>
               </a:rPr>
-              <a:t>Buch und Hefter zu! Die Karten an der Tafel sind abgedeckt.</a:t>
+              <a:t>Teil A ist fertig – jetzt Teil B auf eurem Blatt!</a:t>
             </a:r>
             <a:endParaRPr lang="en-US" sz="1600" dirty="0"/>
           </a:p>
@@ -7114,7 +7114,7 @@
                 <a:ea typeface="Calibri" pitchFamily="34" charset="-122"/>
                 <a:cs typeface="Calibri" pitchFamily="34" charset="-120"/>
               </a:rPr>
-              <a:t>SO SCHREIBT IHR INS HEFT</a:t>
+              <a:t>SO SCHREIBT IHR (BLATT, TEIL A)</a:t>
             </a:r>
             <a:endParaRPr lang="en-US" sz="1000" dirty="0"/>
           </a:p>
@@ -7311,7 +7311,7 @@
                 <a:ea typeface="Calibri" pitchFamily="34" charset="-122"/>
                 <a:cs typeface="Calibri" pitchFamily="34" charset="-120"/>
               </a:rPr>
-              <a:t>PARTNERARBEIT · HEFT</a:t>
+              <a:t>PARTNERARBEIT · BLATT TEIL A</a:t>
             </a:r>
             <a:endParaRPr lang="en-US" sz="1100" dirty="0"/>
           </a:p>
@@ -7553,7 +7553,7 @@
                 <a:ea typeface="Calibri" pitchFamily="34" charset="-122"/>
                 <a:cs typeface="Calibri" pitchFamily="34" charset="-120"/>
               </a:rPr>
-              <a:t>Sucht im Buchtext an der Wand: Was tut Peisistratos für sie (oder mit ihr)?</a:t>
+              <a:t>Sucht im Buchtext (Blatt, Teil A): Was tut Peisistratos für sie (oder mit ihr)?</a:t>
             </a:r>
             <a:endParaRPr lang="en-US" sz="1350" dirty="0"/>
           </a:p>
@@ -7793,7 +7793,7 @@
                 <a:ea typeface="Calibri" pitchFamily="34" charset="-122"/>
                 <a:cs typeface="Calibri" pitchFamily="34" charset="-120"/>
               </a:rPr>
-              <a:t>Schreibt beide ins Heft: „… bekommt Hilfe, weil Peisistratos … Er gewinnt dadurch …“</a:t>
+              <a:t>Schreibt eure Antworten jeder auf sein Blatt (Teil A). Teil B bleibt noch leer!</a:t>
             </a:r>
             <a:endParaRPr lang="en-US" sz="1350" dirty="0"/>
           </a:p>

</xml_diff>

<commit_message>
Peisistratos: Schaubild (Teil B) parallel zum Tafel-Puzzle ausfüllen; Folien auf 12 gestrafft, Handreichung und PDFs aktualisiert
Co-Authored-By: Claude Opus 5.5 <noreply@anthropic.com>
Claude-Session: https://claude.ai/code/session_013iN4Tiarea1J9YUJHZ9iqC
</commit_message>
<xml_diff>
--- a/Geschichte_11/Stunde_Peisistratos/Folien_Peisistratos.pptx
+++ b/Geschichte_11/Stunde_Peisistratos/Folien_Peisistratos.pptx
@@ -17,11 +17,9 @@
     <p:sldId id="265" r:id="rId11"/>
     <p:sldId id="266" r:id="rId12"/>
     <p:sldId id="267" r:id="rId13"/>
-    <p:sldId id="268" r:id="rId14"/>
-    <p:sldId id="269" r:id="rId15"/>
   </p:sldIdLst>
   <p:notesMasterIdLst>
-    <p:notesMasterId r:id="rId16"/>
+    <p:notesMasterId r:id="rId14"/>
   </p:notesMasterIdLst>
   <p:sldSz cx="9144000" cy="5143500"/>
   <p:notesSz cx="5143500" cy="9144000"/>
@@ -603,7 +601,7 @@
           <a:p>
             <a:r>
               <a:rPr lang="en-US" dirty="0"/>
-              <a:t>29–32 Min. Punkte nacheinander aufdecken lassen (oder vorlesen). Rückbezug zur Daumenabfrage: Die meisten sagten Nein – das Buch sagt: ja, ungewollt. Demokratie = alle Bürger entscheiden gleichberechtigt mit (Wiederholung aus der letzten Stunde).</a:t>
+              <a:t>32–36 Min. Punkte nacheinander aufdecken lassen (oder vorlesen). Rückbezug zur Daumenabfrage: Die meisten sagten Nein – das Buch sagt: ja, ungewollt. Demokratie = alle Bürger entscheiden gleichberechtigt mit (Wiederholung aus der letzten Stunde).</a:t>
             </a:r>
             <a:endParaRPr lang="en-US" dirty="0"/>
           </a:p>
@@ -691,7 +689,7 @@
           <a:p>
             <a:r>
               <a:rPr lang="en-US" dirty="0"/>
-              <a:t>32–40 Min. Karten an der Tafel abdecken oder abnehmen. Dasselbe Gerüst an die Tafel zeichnen (Skizze in der Handreichung) und gemeinsam füllen – jeder schreibt auf seinem Blatt (Teil B) mit. Fragen dabei klären. Blatt in den Hefter.</a:t>
+              <a:t>36–41 Min. Einsammeln: Zeigt, wer den Zusammenhang „Tyrann – und trotzdem Schritt zur Demokratie“ verstanden hat. Die Beispiellösung (nächste Folie) erst nach dem Einsammeln zeigen.</a:t>
             </a:r>
             <a:endParaRPr lang="en-US" dirty="0"/>
           </a:p>
@@ -779,7 +777,7 @@
           <a:p>
             <a:r>
               <a:rPr lang="en-US" dirty="0"/>
-              <a:t>40 Min. Selbstkontrolle, Fehler farbig markieren.</a:t>
+              <a:t>Nach dem Einsammeln zeigen oder in der nächsten Stunde als Einstieg nutzen.</a:t>
             </a:r>
             <a:endParaRPr lang="en-US" dirty="0"/>
           </a:p>
@@ -803,182 +801,6 @@
             <a:fld id="{F7021451-1387-4CA6-816F-3879F97B5CBC}" type="slidenum">
               <a:rPr lang="en-US"/>
               <a:t>12</a:t>
-            </a:fld>
-            <a:endParaRPr lang="en-US"/>
-          </a:p>
-        </p:txBody>
-      </p:sp>
-    </p:spTree>
-    <p:extLst>
-      <p:ext uri="{BB962C8B-B14F-4D97-AF65-F5344CB8AC3E}">
-        <p14:creationId xmlns:p14="http://schemas.microsoft.com/office/powerpoint/2010/main" val="1024086991"/>
-      </p:ext>
-    </p:extLst>
-  </p:cSld>
-  <p:clrMapOvr>
-    <a:masterClrMapping/>
-  </p:clrMapOvr>
-</p:notes>
-</file>
-
-<file path=ppt/notesSlides/notesSlide13.xml><?xml version="1.0" encoding="utf-8"?>
-<p:notes xmlns:a="http://schemas.openxmlformats.org/drawingml/2006/main" xmlns:r="http://schemas.openxmlformats.org/officeDocument/2006/relationships" xmlns:p="http://schemas.openxmlformats.org/presentationml/2006/main">
-  <p:cSld>
-    <p:spTree>
-      <p:nvGrpSpPr>
-        <p:cNvPr id="1" name=""/>
-        <p:cNvGrpSpPr/>
-        <p:nvPr/>
-      </p:nvGrpSpPr>
-      <p:grpSpPr>
-        <a:xfrm>
-          <a:off x="0" y="0"/>
-          <a:ext cx="0" cy="0"/>
-          <a:chOff x="0" y="0"/>
-          <a:chExt cx="0" cy="0"/>
-        </a:xfrm>
-      </p:grpSpPr>
-      <p:sp>
-        <p:nvSpPr>
-          <p:cNvPr id="2" name="Slide Image Placeholder 1"/>
-          <p:cNvSpPr>
-            <a:spLocks noGrp="1" noRot="1" noChangeAspect="1"/>
-          </p:cNvSpPr>
-          <p:nvPr>
-            <p:ph type="sldImg"/>
-          </p:nvPr>
-        </p:nvSpPr>
-        <p:spPr/>
-      </p:sp>
-      <p:sp>
-        <p:nvSpPr>
-          <p:cNvPr id="3" name="Notes Placeholder 2"/>
-          <p:cNvSpPr>
-            <a:spLocks noGrp="1"/>
-          </p:cNvSpPr>
-          <p:nvPr>
-            <p:ph type="body" idx="1"/>
-          </p:nvPr>
-        </p:nvSpPr>
-        <p:spPr/>
-        <p:txBody>
-          <a:bodyPr/>
-          <a:lstStyle/>
-          <a:p>
-            <a:r>
-              <a:rPr lang="en-US" dirty="0"/>
-              <a:t>41–45 Min. Einsammeln: Zeigt, wer den Zusammenhang „Tyrann – und trotzdem Schritt zur Demokratie“ verstanden hat. Die Beispiellösung (nächste Folie) erst nach dem Einsammeln zeigen.</a:t>
-            </a:r>
-            <a:endParaRPr lang="en-US" dirty="0"/>
-          </a:p>
-        </p:txBody>
-      </p:sp>
-      <p:sp>
-        <p:nvSpPr>
-          <p:cNvPr id="4" name="Slide Number Placeholder 3"/>
-          <p:cNvSpPr>
-            <a:spLocks noGrp="1"/>
-          </p:cNvSpPr>
-          <p:nvPr>
-            <p:ph type="sldNum" sz="quarter" idx="10"/>
-          </p:nvPr>
-        </p:nvSpPr>
-        <p:spPr/>
-        <p:txBody>
-          <a:bodyPr/>
-          <a:lstStyle/>
-          <a:p>
-            <a:fld id="{F7021451-1387-4CA6-816F-3879F97B5CBC}" type="slidenum">
-              <a:rPr lang="en-US"/>
-              <a:t>13</a:t>
-            </a:fld>
-            <a:endParaRPr lang="en-US"/>
-          </a:p>
-        </p:txBody>
-      </p:sp>
-    </p:spTree>
-    <p:extLst>
-      <p:ext uri="{BB962C8B-B14F-4D97-AF65-F5344CB8AC3E}">
-        <p14:creationId xmlns:p14="http://schemas.microsoft.com/office/powerpoint/2010/main" val="1024086991"/>
-      </p:ext>
-    </p:extLst>
-  </p:cSld>
-  <p:clrMapOvr>
-    <a:masterClrMapping/>
-  </p:clrMapOvr>
-</p:notes>
-</file>
-
-<file path=ppt/notesSlides/notesSlide14.xml><?xml version="1.0" encoding="utf-8"?>
-<p:notes xmlns:a="http://schemas.openxmlformats.org/drawingml/2006/main" xmlns:r="http://schemas.openxmlformats.org/officeDocument/2006/relationships" xmlns:p="http://schemas.openxmlformats.org/presentationml/2006/main">
-  <p:cSld>
-    <p:spTree>
-      <p:nvGrpSpPr>
-        <p:cNvPr id="1" name=""/>
-        <p:cNvGrpSpPr/>
-        <p:nvPr/>
-      </p:nvGrpSpPr>
-      <p:grpSpPr>
-        <a:xfrm>
-          <a:off x="0" y="0"/>
-          <a:ext cx="0" cy="0"/>
-          <a:chOff x="0" y="0"/>
-          <a:chExt cx="0" cy="0"/>
-        </a:xfrm>
-      </p:grpSpPr>
-      <p:sp>
-        <p:nvSpPr>
-          <p:cNvPr id="2" name="Slide Image Placeholder 1"/>
-          <p:cNvSpPr>
-            <a:spLocks noGrp="1" noRot="1" noChangeAspect="1"/>
-          </p:cNvSpPr>
-          <p:nvPr>
-            <p:ph type="sldImg"/>
-          </p:nvPr>
-        </p:nvSpPr>
-        <p:spPr/>
-      </p:sp>
-      <p:sp>
-        <p:nvSpPr>
-          <p:cNvPr id="3" name="Notes Placeholder 2"/>
-          <p:cNvSpPr>
-            <a:spLocks noGrp="1"/>
-          </p:cNvSpPr>
-          <p:nvPr>
-            <p:ph type="body" idx="1"/>
-          </p:nvPr>
-        </p:nvSpPr>
-        <p:spPr/>
-        <p:txBody>
-          <a:bodyPr/>
-          <a:lstStyle/>
-          <a:p>
-            <a:r>
-              <a:rPr lang="en-US" dirty="0"/>
-              <a:t>Nach dem Einsammeln zeigen oder in der nächsten Stunde als Einstieg nutzen.</a:t>
-            </a:r>
-            <a:endParaRPr lang="en-US" dirty="0"/>
-          </a:p>
-        </p:txBody>
-      </p:sp>
-      <p:sp>
-        <p:nvSpPr>
-          <p:cNvPr id="4" name="Slide Number Placeholder 3"/>
-          <p:cNvSpPr>
-            <a:spLocks noGrp="1"/>
-          </p:cNvSpPr>
-          <p:nvPr>
-            <p:ph type="sldNum" sz="quarter" idx="10"/>
-          </p:nvPr>
-        </p:nvSpPr>
-        <p:spPr/>
-        <p:txBody>
-          <a:bodyPr/>
-          <a:lstStyle/>
-          <a:p>
-            <a:fld id="{F7021451-1387-4CA6-816F-3879F97B5CBC}" type="slidenum">
-              <a:rPr lang="en-US"/>
-              <a:t>14</a:t>
             </a:fld>
             <a:endParaRPr lang="en-US"/>
           </a:p>
@@ -1571,7 +1393,7 @@
           <a:p>
             <a:r>
               <a:rPr lang="en-US" dirty="0"/>
-              <a:t>18–27 Min. Reihenfolge 1–9 (ohne 5, die hängt schon). Bei Fehlern nicht selbst korrigieren: „Stimmt ihr zu? Was steht im Text?“ Zwei Zuordnungen sind vertretbar (Weinbauer: Bauern oder Mittelstand; Homer: Volk) – die Begründung zählt.</a:t>
+              <a:t>18–30 Min. Reihenfolge 1–9 (ohne 5, die hängt schon). Nach jeder Karte kurz Zeit lassen, damit alle in Teil B eintragen. Bei Fehlern nicht selbst korrigieren: „Stimmt ihr zu? Was steht im Text?“ Zwei Zuordnungen sind vertretbar (Weinbauer: Bauern oder Mittelstand; Homer: Volk) – die Begründung zählt.</a:t>
             </a:r>
             <a:endParaRPr lang="en-US" dirty="0"/>
           </a:p>
@@ -1659,7 +1481,7 @@
           <a:p>
             <a:r>
               <a:rPr lang="en-US" dirty="0"/>
-              <a:t>27–29 Min. Still vergleichen. Impuls: Fast alle gewinnen – nur die mächtigsten Gegner aus dem Adel verlieren.</a:t>
+              <a:t>30–32 Min. Still vergleichen, Fehler farbig markieren. Impuls: Fast alle gewinnen – nur die mächtigsten Gegner aus dem Adel verlieren.</a:t>
             </a:r>
             <a:endParaRPr lang="en-US" dirty="0"/>
           </a:p>
@@ -3093,7 +2915,7 @@
                 <a:ea typeface="Calibri" pitchFamily="34" charset="-122"/>
                 <a:cs typeface="Calibri" pitchFamily="34" charset="-120"/>
               </a:rPr>
-              <a:t>SICHERUNG · BLATT TEIL B · TAFEL</a:t>
+              <a:t>EINZELARBEIT · ZETTEL</a:t>
             </a:r>
             <a:endParaRPr lang="en-US" sz="1100" dirty="0"/>
           </a:p>
@@ -3132,7 +2954,7 @@
                 <a:ea typeface="Cambria" pitchFamily="34" charset="-122"/>
                 <a:cs typeface="Cambria" pitchFamily="34" charset="-120"/>
               </a:rPr>
-              <a:t>Das ganze Bild auf euer Blatt</a:t>
+              <a:t>Ausgangskarte</a:t>
             </a:r>
             <a:endParaRPr lang="en-US" sz="2800" dirty="0"/>
           </a:p>
@@ -3175,7 +2997,7 @@
                 <a:ea typeface="Calibri" pitchFamily="34" charset="-122"/>
                 <a:cs typeface="Calibri" pitchFamily="34" charset="-120"/>
               </a:rPr>
-              <a:t>8 Min.</a:t>
+              <a:t>4 Min.</a:t>
             </a:r>
             <a:endParaRPr lang="en-US" sz="1100" dirty="0"/>
           </a:p>
@@ -3189,73 +3011,153 @@
         </p:nvSpPr>
         <p:spPr>
           <a:xfrm>
-            <a:off x="457200" y="1188720"/>
-            <a:ext cx="8229600" cy="548640"/>
+            <a:off x="457200" y="1371600"/>
+            <a:ext cx="8229600" cy="1280160"/>
           </a:xfrm>
           <a:prstGeom prst="roundRect">
             <a:avLst>
-              <a:gd name="adj" fmla="val 13333"/>
+              <a:gd name="adj" fmla="val 5714"/>
             </a:avLst>
+          </a:prstGeom>
+          <a:solidFill>
+            <a:srgbClr val="2B2318"/>
+          </a:solidFill>
+          <a:ln w="12700">
+            <a:solidFill>
+              <a:srgbClr val="2B2318"/>
+            </a:solidFill>
+            <a:prstDash val="solid"/>
+          </a:ln>
+        </p:spPr>
+      </p:sp>
+      <p:sp>
+        <p:nvSpPr>
+          <p:cNvPr id="6" name="Text 4"/>
+          <p:cNvSpPr txBox="1"/>
+          <p:nvPr/>
+        </p:nvSpPr>
+        <p:spPr>
+          <a:xfrm>
+            <a:off x="731520" y="1371600"/>
+            <a:ext cx="7680960" cy="1280160"/>
+          </a:xfrm>
+          <a:prstGeom prst="rect">
+            <a:avLst/>
+          </a:prstGeom>
+          <a:noFill/>
+          <a:ln/>
+        </p:spPr>
+        <p:txBody>
+          <a:bodyPr wrap="square" lIns="0" tIns="0" rIns="0" bIns="0" rtlCol="0" anchor="ctr"/>
+          <a:lstStyle/>
+          <a:p>
+            <a:pPr indent="0" marL="0">
+              <a:buNone/>
+            </a:pPr>
+            <a:r>
+              <a:rPr lang="en-US" sz="2600" b="1" dirty="0">
+                <a:solidFill>
+                  <a:srgbClr val="FFFFFF"/>
+                </a:solidFill>
+                <a:latin typeface="Cambria" pitchFamily="34" charset="0"/>
+                <a:ea typeface="Cambria" pitchFamily="34" charset="-122"/>
+                <a:cs typeface="Cambria" pitchFamily="34" charset="-120"/>
+              </a:rPr>
+              <a:t>„Peisistratos war ein Tyrann, aber …, weil …“</a:t>
+            </a:r>
+            <a:endParaRPr lang="en-US" sz="2600" dirty="0"/>
+          </a:p>
+        </p:txBody>
+      </p:sp>
+      <p:sp>
+        <p:nvSpPr>
+          <p:cNvPr id="7" name="Text 5"/>
+          <p:cNvSpPr txBox="1"/>
+          <p:nvPr/>
+        </p:nvSpPr>
+        <p:spPr>
+          <a:xfrm>
+            <a:off x="457200" y="2926080"/>
+            <a:ext cx="365760" cy="365760"/>
+          </a:xfrm>
+          <a:prstGeom prst="ellipse">
+            <a:avLst/>
           </a:prstGeom>
           <a:solidFill>
             <a:srgbClr val="AD4426"/>
           </a:solidFill>
-          <a:ln w="12700">
-            <a:solidFill>
-              <a:srgbClr val="AD4426"/>
-            </a:solidFill>
-            <a:prstDash val="solid"/>
-          </a:ln>
-        </p:spPr>
-      </p:sp>
-      <p:sp>
-        <p:nvSpPr>
-          <p:cNvPr id="6" name="Text 4"/>
-          <p:cNvSpPr txBox="1"/>
-          <p:nvPr/>
-        </p:nvSpPr>
-        <p:spPr>
-          <a:xfrm>
-            <a:off x="685800" y="1188720"/>
-            <a:ext cx="7772400" cy="548640"/>
-          </a:xfrm>
-          <a:prstGeom prst="rect">
-            <a:avLst/>
-          </a:prstGeom>
-          <a:noFill/>
           <a:ln/>
         </p:spPr>
         <p:txBody>
           <a:bodyPr wrap="square" lIns="0" tIns="0" rIns="0" bIns="0" rtlCol="0" anchor="ctr"/>
           <a:lstStyle/>
           <a:p>
-            <a:pPr indent="0" marL="0">
-              <a:buNone/>
-            </a:pPr>
-            <a:r>
-              <a:rPr lang="en-US" sz="1600" b="1" dirty="0">
+            <a:pPr algn="ctr" indent="0" marL="0">
+              <a:buNone/>
+            </a:pPr>
+            <a:r>
+              <a:rPr lang="en-US" sz="1400" b="1" dirty="0">
                 <a:solidFill>
                   <a:srgbClr val="FFFFFF"/>
                 </a:solidFill>
-                <a:latin typeface="Calibri" pitchFamily="34" charset="0"/>
-                <a:ea typeface="Calibri" pitchFamily="34" charset="-122"/>
-                <a:cs typeface="Calibri" pitchFamily="34" charset="-120"/>
-              </a:rPr>
-              <a:t>Teil A ist fertig – jetzt Teil B auf eurem Blatt!</a:t>
-            </a:r>
-            <a:endParaRPr lang="en-US" sz="1600" dirty="0"/>
-          </a:p>
-        </p:txBody>
-      </p:sp>
-      <p:sp>
-        <p:nvSpPr>
-          <p:cNvPr id="7" name="Text 5"/>
-          <p:cNvSpPr txBox="1"/>
-          <p:nvPr/>
-        </p:nvSpPr>
-        <p:spPr>
-          <a:xfrm>
-            <a:off x="457200" y="1920240"/>
+                <a:latin typeface="Cambria" pitchFamily="34" charset="0"/>
+                <a:ea typeface="Cambria" pitchFamily="34" charset="-122"/>
+                <a:cs typeface="Cambria" pitchFamily="34" charset="-120"/>
+              </a:rPr>
+              <a:t>1</a:t>
+            </a:r>
+            <a:endParaRPr lang="en-US" sz="1400" dirty="0"/>
+          </a:p>
+        </p:txBody>
+      </p:sp>
+      <p:sp>
+        <p:nvSpPr>
+          <p:cNvPr id="8" name="Text 6"/>
+          <p:cNvSpPr txBox="1"/>
+          <p:nvPr/>
+        </p:nvSpPr>
+        <p:spPr>
+          <a:xfrm>
+            <a:off x="960120" y="2889504"/>
+            <a:ext cx="7726680" cy="493776"/>
+          </a:xfrm>
+          <a:prstGeom prst="rect">
+            <a:avLst/>
+          </a:prstGeom>
+          <a:noFill/>
+          <a:ln/>
+        </p:spPr>
+        <p:txBody>
+          <a:bodyPr wrap="square" lIns="0" tIns="0" rIns="0" bIns="0" rtlCol="0" anchor="ctr"/>
+          <a:lstStyle/>
+          <a:p>
+            <a:pPr indent="0" marL="0">
+              <a:buNone/>
+            </a:pPr>
+            <a:r>
+              <a:rPr lang="en-US" sz="1400" dirty="0">
+                <a:solidFill>
+                  <a:srgbClr val="2B2318"/>
+                </a:solidFill>
+                <a:latin typeface="Calibri" pitchFamily="34" charset="0"/>
+                <a:ea typeface="Calibri" pitchFamily="34" charset="-122"/>
+                <a:cs typeface="Calibri" pitchFamily="34" charset="-120"/>
+              </a:rPr>
+              <a:t>Ergänze den Satz auf einem Zettel mit Namen.</a:t>
+            </a:r>
+            <a:endParaRPr lang="en-US" sz="1400" dirty="0"/>
+          </a:p>
+        </p:txBody>
+      </p:sp>
+      <p:sp>
+        <p:nvSpPr>
+          <p:cNvPr id="9" name="Text 7"/>
+          <p:cNvSpPr txBox="1"/>
+          <p:nvPr/>
+        </p:nvSpPr>
+        <p:spPr>
+          <a:xfrm>
+            <a:off x="457200" y="3456432"/>
             <a:ext cx="365760" cy="365760"/>
           </a:xfrm>
           <a:prstGeom prst="ellipse">
@@ -3282,7 +3184,7 @@
                 <a:ea typeface="Cambria" pitchFamily="34" charset="-122"/>
                 <a:cs typeface="Cambria" pitchFamily="34" charset="-120"/>
               </a:rPr>
-              <a:t>1</a:t>
+              <a:t>2</a:t>
             </a:r>
             <a:endParaRPr lang="en-US" sz="1400" dirty="0"/>
           </a:p>
@@ -3290,14 +3192,14 @@
       </p:sp>
       <p:sp>
         <p:nvSpPr>
-          <p:cNvPr id="8" name="Text 6"/>
-          <p:cNvSpPr txBox="1"/>
-          <p:nvPr/>
-        </p:nvSpPr>
-        <p:spPr>
-          <a:xfrm>
-            <a:off x="960120" y="1883664"/>
-            <a:ext cx="4343400" cy="621792"/>
+          <p:cNvPr id="10" name="Text 8"/>
+          <p:cNvSpPr txBox="1"/>
+          <p:nvPr/>
+        </p:nvSpPr>
+        <p:spPr>
+          <a:xfrm>
+            <a:off x="960120" y="3419856"/>
+            <a:ext cx="7726680" cy="493776"/>
           </a:xfrm>
           <a:prstGeom prst="rect">
             <a:avLst/>
@@ -3313,7 +3215,7 @@
               <a:buNone/>
             </a:pPr>
             <a:r>
-              <a:rPr lang="en-US" sz="1300" dirty="0">
+              <a:rPr lang="en-US" sz="1400" dirty="0">
                 <a:solidFill>
                   <a:srgbClr val="2B2318"/>
                 </a:solidFill>
@@ -3321,21 +3223,21 @@
                 <a:ea typeface="Calibri" pitchFamily="34" charset="-122"/>
                 <a:cs typeface="Calibri" pitchFamily="34" charset="-120"/>
               </a:rPr>
-              <a:t>Trage in die Mitte und in die vier Felder ein, wer gemeint ist.</a:t>
-            </a:r>
-            <a:endParaRPr lang="en-US" sz="1300" dirty="0"/>
-          </a:p>
-        </p:txBody>
-      </p:sp>
-      <p:sp>
-        <p:nvSpPr>
-          <p:cNvPr id="9" name="Text 7"/>
-          <p:cNvSpPr txBox="1"/>
-          <p:nvPr/>
-        </p:nvSpPr>
-        <p:spPr>
-          <a:xfrm>
-            <a:off x="457200" y="2578608"/>
+              <a:t>Nenne mindestens eine Maßnahme als Beleg.</a:t>
+            </a:r>
+            <a:endParaRPr lang="en-US" sz="1400" dirty="0"/>
+          </a:p>
+        </p:txBody>
+      </p:sp>
+      <p:sp>
+        <p:nvSpPr>
+          <p:cNvPr id="11" name="Text 9"/>
+          <p:cNvSpPr txBox="1"/>
+          <p:nvPr/>
+        </p:nvSpPr>
+        <p:spPr>
+          <a:xfrm>
+            <a:off x="457200" y="3986784"/>
             <a:ext cx="365760" cy="365760"/>
           </a:xfrm>
           <a:prstGeom prst="ellipse">
@@ -3362,7 +3264,7 @@
                 <a:ea typeface="Cambria" pitchFamily="34" charset="-122"/>
                 <a:cs typeface="Cambria" pitchFamily="34" charset="-120"/>
               </a:rPr>
-              <a:t>2</a:t>
+              <a:t>3</a:t>
             </a:r>
             <a:endParaRPr lang="en-US" sz="1400" dirty="0"/>
           </a:p>
@@ -3370,14 +3272,14 @@
       </p:sp>
       <p:sp>
         <p:nvSpPr>
-          <p:cNvPr id="10" name="Text 8"/>
-          <p:cNvSpPr txBox="1"/>
-          <p:nvPr/>
-        </p:nvSpPr>
-        <p:spPr>
-          <a:xfrm>
-            <a:off x="960120" y="2542032"/>
-            <a:ext cx="4343400" cy="621792"/>
+          <p:cNvPr id="12" name="Text 10"/>
+          <p:cNvSpPr txBox="1"/>
+          <p:nvPr/>
+        </p:nvSpPr>
+        <p:spPr>
+          <a:xfrm>
+            <a:off x="960120" y="3950208"/>
+            <a:ext cx="7726680" cy="493776"/>
           </a:xfrm>
           <a:prstGeom prst="rect">
             <a:avLst/>
@@ -3393,7 +3295,7 @@
               <a:buNone/>
             </a:pPr>
             <a:r>
-              <a:rPr lang="en-US" sz="1300" dirty="0">
+              <a:rPr lang="en-US" sz="1400" dirty="0">
                 <a:solidFill>
                   <a:srgbClr val="2B2318"/>
                 </a:solidFill>
@@ -3401,48 +3303,7 @@
                 <a:ea typeface="Calibri" pitchFamily="34" charset="-122"/>
                 <a:cs typeface="Calibri" pitchFamily="34" charset="-120"/>
               </a:rPr>
-              <a:t>Schreibe in jedes Feld mindestens eine Maßnahme. Beim Adel: ✓ wer gewinnt, ✗ wer verliert.</a:t>
-            </a:r>
-            <a:endParaRPr lang="en-US" sz="1300" dirty="0"/>
-          </a:p>
-        </p:txBody>
-      </p:sp>
-      <p:sp>
-        <p:nvSpPr>
-          <p:cNvPr id="11" name="Text 9"/>
-          <p:cNvSpPr txBox="1"/>
-          <p:nvPr/>
-        </p:nvSpPr>
-        <p:spPr>
-          <a:xfrm>
-            <a:off x="457200" y="3236976"/>
-            <a:ext cx="365760" cy="365760"/>
-          </a:xfrm>
-          <a:prstGeom prst="ellipse">
-            <a:avLst/>
-          </a:prstGeom>
-          <a:solidFill>
-            <a:srgbClr val="AD4426"/>
-          </a:solidFill>
-          <a:ln/>
-        </p:spPr>
-        <p:txBody>
-          <a:bodyPr wrap="square" lIns="0" tIns="0" rIns="0" bIns="0" rtlCol="0" anchor="ctr"/>
-          <a:lstStyle/>
-          <a:p>
-            <a:pPr algn="ctr" indent="0" marL="0">
-              <a:buNone/>
-            </a:pPr>
-            <a:r>
-              <a:rPr lang="en-US" sz="1400" b="1" dirty="0">
-                <a:solidFill>
-                  <a:srgbClr val="FFFFFF"/>
-                </a:solidFill>
-                <a:latin typeface="Cambria" pitchFamily="34" charset="0"/>
-                <a:ea typeface="Cambria" pitchFamily="34" charset="-122"/>
-                <a:cs typeface="Cambria" pitchFamily="34" charset="-120"/>
-              </a:rPr>
-              <a:t>3</a:t>
+              <a:t>Gib den Zettel beim Rausgehen ab.</a:t>
             </a:r>
             <a:endParaRPr lang="en-US" sz="1400" dirty="0"/>
           </a:p>
@@ -3450,150 +3311,7 @@
       </p:sp>
       <p:sp>
         <p:nvSpPr>
-          <p:cNvPr id="12" name="Text 10"/>
-          <p:cNvSpPr txBox="1"/>
-          <p:nvPr/>
-        </p:nvSpPr>
-        <p:spPr>
-          <a:xfrm>
-            <a:off x="960120" y="3200400"/>
-            <a:ext cx="4343400" cy="621792"/>
-          </a:xfrm>
-          <a:prstGeom prst="rect">
-            <a:avLst/>
-          </a:prstGeom>
-          <a:noFill/>
-          <a:ln/>
-        </p:spPr>
-        <p:txBody>
-          <a:bodyPr wrap="square" lIns="0" tIns="0" rIns="0" bIns="0" rtlCol="0" anchor="ctr"/>
-          <a:lstStyle/>
-          <a:p>
-            <a:pPr indent="0" marL="0">
-              <a:buNone/>
-            </a:pPr>
-            <a:r>
-              <a:rPr lang="en-US" sz="1300" dirty="0">
-                <a:solidFill>
-                  <a:srgbClr val="2B2318"/>
-                </a:solidFill>
-                <a:latin typeface="Calibri" pitchFamily="34" charset="0"/>
-                <a:ea typeface="Calibri" pitchFamily="34" charset="-122"/>
-                <a:cs typeface="Calibri" pitchFamily="34" charset="-120"/>
-              </a:rPr>
-              <a:t>Was bedeuten die dunklen, was die hellen Pfeile?</a:t>
-            </a:r>
-            <a:endParaRPr lang="en-US" sz="1300" dirty="0"/>
-          </a:p>
-        </p:txBody>
-      </p:sp>
-      <p:sp>
-        <p:nvSpPr>
           <p:cNvPr id="13" name="Text 11"/>
-          <p:cNvSpPr txBox="1"/>
-          <p:nvPr/>
-        </p:nvSpPr>
-        <p:spPr>
-          <a:xfrm>
-            <a:off x="457200" y="3895344"/>
-            <a:ext cx="365760" cy="365760"/>
-          </a:xfrm>
-          <a:prstGeom prst="ellipse">
-            <a:avLst/>
-          </a:prstGeom>
-          <a:solidFill>
-            <a:srgbClr val="AD4426"/>
-          </a:solidFill>
-          <a:ln/>
-        </p:spPr>
-        <p:txBody>
-          <a:bodyPr wrap="square" lIns="0" tIns="0" rIns="0" bIns="0" rtlCol="0" anchor="ctr"/>
-          <a:lstStyle/>
-          <a:p>
-            <a:pPr algn="ctr" indent="0" marL="0">
-              <a:buNone/>
-            </a:pPr>
-            <a:r>
-              <a:rPr lang="en-US" sz="1400" b="1" dirty="0">
-                <a:solidFill>
-                  <a:srgbClr val="FFFFFF"/>
-                </a:solidFill>
-                <a:latin typeface="Cambria" pitchFamily="34" charset="0"/>
-                <a:ea typeface="Cambria" pitchFamily="34" charset="-122"/>
-                <a:cs typeface="Cambria" pitchFamily="34" charset="-120"/>
-              </a:rPr>
-              <a:t>4</a:t>
-            </a:r>
-            <a:endParaRPr lang="en-US" sz="1400" dirty="0"/>
-          </a:p>
-        </p:txBody>
-      </p:sp>
-      <p:sp>
-        <p:nvSpPr>
-          <p:cNvPr id="14" name="Text 12"/>
-          <p:cNvSpPr txBox="1"/>
-          <p:nvPr/>
-        </p:nvSpPr>
-        <p:spPr>
-          <a:xfrm>
-            <a:off x="960120" y="3858768"/>
-            <a:ext cx="4343400" cy="621792"/>
-          </a:xfrm>
-          <a:prstGeom prst="rect">
-            <a:avLst/>
-          </a:prstGeom>
-          <a:noFill/>
-          <a:ln/>
-        </p:spPr>
-        <p:txBody>
-          <a:bodyPr wrap="square" lIns="0" tIns="0" rIns="0" bIns="0" rtlCol="0" anchor="ctr"/>
-          <a:lstStyle/>
-          <a:p>
-            <a:pPr indent="0" marL="0">
-              <a:buNone/>
-            </a:pPr>
-            <a:r>
-              <a:rPr lang="en-US" sz="1300" dirty="0">
-                <a:solidFill>
-                  <a:srgbClr val="2B2318"/>
-                </a:solidFill>
-                <a:latin typeface="Calibri" pitchFamily="34" charset="0"/>
-                <a:ea typeface="Calibri" pitchFamily="34" charset="-122"/>
-                <a:cs typeface="Calibri" pitchFamily="34" charset="-120"/>
-              </a:rPr>
-              <a:t>Ergänze den Merksatz: „Peisistratos sichert seine Macht durch …“</a:t>
-            </a:r>
-            <a:endParaRPr lang="en-US" sz="1300" dirty="0"/>
-          </a:p>
-        </p:txBody>
-      </p:sp>
-      <p:pic>
-        <p:nvPicPr>
-          <p:cNvPr id="15" name="Image 0" descr="/tmp/claude-0/-home-user-Schule/9be99485-7769-5631-81b2-1e426720ceab/scratchpad/pei/tafel_stumm.png">    </p:cNvPr>
-          <p:cNvPicPr>
-            <a:picLocks noChangeAspect="1"/>
-          </p:cNvPicPr>
-          <p:nvPr/>
-        </p:nvPicPr>
-        <p:blipFill>
-          <a:blip r:embed="rId1"/>
-          <a:stretch>
-            <a:fillRect/>
-          </a:stretch>
-        </p:blipFill>
-        <p:spPr>
-          <a:xfrm>
-            <a:off x="5486400" y="1920240"/>
-            <a:ext cx="3200400" cy="2121408"/>
-          </a:xfrm>
-          <a:prstGeom prst="rect">
-            <a:avLst/>
-          </a:prstGeom>
-        </p:spPr>
-      </p:pic>
-      <p:sp>
-        <p:nvSpPr>
-          <p:cNvPr id="16" name="Text 13"/>
           <p:cNvSpPr txBox="1"/>
           <p:nvPr/>
         </p:nvSpPr>
@@ -3743,7 +3461,7 @@
                 <a:ea typeface="Calibri" pitchFamily="34" charset="-122"/>
                 <a:cs typeface="Calibri" pitchFamily="34" charset="-120"/>
               </a:rPr>
-              <a:t>SICHERUNG · LÖSUNG</a:t>
+              <a:t>AUSGANGSKARTE · BEISPIEL</a:t>
             </a:r>
             <a:endParaRPr lang="en-US" sz="1100" dirty="0"/>
           </a:p>
@@ -3782,7 +3500,7 @@
                 <a:ea typeface="Cambria" pitchFamily="34" charset="-122"/>
                 <a:cs typeface="Cambria" pitchFamily="34" charset="-120"/>
               </a:rPr>
-              <a:t>Vergleicht mit eurem Blatt</a:t>
+              <a:t>So könnte dein Satz lauten</a:t>
             </a:r>
             <a:endParaRPr lang="en-US" sz="2800" dirty="0"/>
           </a:p>
@@ -3831,44 +3549,20 @@
           </a:p>
         </p:txBody>
       </p:sp>
-      <p:pic>
-        <p:nvPicPr>
-          <p:cNvPr id="5" name="Image 0" descr="/tmp/claude-0/-home-user-Schule/9be99485-7769-5631-81b2-1e426720ceab/scratchpad/pei/tafel_loesung.png">    </p:cNvPr>
-          <p:cNvPicPr>
-            <a:picLocks noChangeAspect="1"/>
-          </p:cNvPicPr>
-          <p:nvPr/>
-        </p:nvPicPr>
-        <p:blipFill>
-          <a:blip r:embed="rId1"/>
-          <a:stretch>
-            <a:fillRect/>
-          </a:stretch>
-        </p:blipFill>
-        <p:spPr>
-          <a:xfrm>
-            <a:off x="457200" y="1188720"/>
-            <a:ext cx="5120640" cy="3392424"/>
-          </a:xfrm>
-          <a:prstGeom prst="rect">
-            <a:avLst/>
-          </a:prstGeom>
-        </p:spPr>
-      </p:pic>
-      <p:sp>
-        <p:nvSpPr>
-          <p:cNvPr id="6" name="Shape 3"/>
+      <p:sp>
+        <p:nvSpPr>
+          <p:cNvPr id="5" name="Shape 3"/>
           <p:cNvSpPr/>
           <p:nvPr/>
         </p:nvSpPr>
         <p:spPr>
           <a:xfrm>
-            <a:off x="5806440" y="1188720"/>
-            <a:ext cx="2880360" cy="3392424"/>
+            <a:off x="457200" y="1280160"/>
+            <a:ext cx="8229600" cy="1737360"/>
           </a:xfrm>
           <a:prstGeom prst="roundRect">
             <a:avLst>
-              <a:gd name="adj" fmla="val 2540"/>
+              <a:gd name="adj" fmla="val 4211"/>
             </a:avLst>
           </a:prstGeom>
           <a:solidFill>
@@ -3884,69 +3578,30 @@
       </p:sp>
       <p:sp>
         <p:nvSpPr>
-          <p:cNvPr id="7" name="Text 4"/>
-          <p:cNvSpPr txBox="1"/>
-          <p:nvPr/>
-        </p:nvSpPr>
-        <p:spPr>
-          <a:xfrm>
-            <a:off x="5989320" y="1280160"/>
-            <a:ext cx="2560320" cy="320040"/>
-          </a:xfrm>
-          <a:prstGeom prst="rect">
-            <a:avLst/>
-          </a:prstGeom>
-          <a:noFill/>
-          <a:ln/>
-        </p:spPr>
-        <p:txBody>
-          <a:bodyPr wrap="square" lIns="0" tIns="0" rIns="0" bIns="0" rtlCol="0" anchor="t"/>
-          <a:lstStyle/>
-          <a:p>
-            <a:pPr indent="0" marL="0">
-              <a:buNone/>
-            </a:pPr>
-            <a:r>
-              <a:rPr lang="en-US" sz="1500" b="1" dirty="0">
-                <a:solidFill>
-                  <a:srgbClr val="AD4426"/>
-                </a:solidFill>
-                <a:latin typeface="Cambria" pitchFamily="34" charset="0"/>
-                <a:ea typeface="Cambria" pitchFamily="34" charset="-122"/>
-                <a:cs typeface="Cambria" pitchFamily="34" charset="-120"/>
-              </a:rPr>
-              <a:t>Die Pfeile</a:t>
-            </a:r>
-            <a:endParaRPr lang="en-US" sz="1500" dirty="0"/>
-          </a:p>
-        </p:txBody>
-      </p:sp>
-      <p:sp>
-        <p:nvSpPr>
-          <p:cNvPr id="8" name="Text 5"/>
-          <p:cNvSpPr txBox="1"/>
-          <p:nvPr/>
-        </p:nvSpPr>
-        <p:spPr>
-          <a:xfrm>
-            <a:off x="5989320" y="1691640"/>
-            <a:ext cx="2560320" cy="2743200"/>
-          </a:xfrm>
-          <a:prstGeom prst="rect">
-            <a:avLst/>
-          </a:prstGeom>
-          <a:noFill/>
-          <a:ln/>
-        </p:spPr>
-        <p:txBody>
-          <a:bodyPr wrap="square" lIns="0" tIns="0" rIns="0" bIns="0" rtlCol="0" anchor="t"/>
-          <a:lstStyle/>
-          <a:p>
-            <a:pPr indent="0" marL="0">
-              <a:buNone/>
-            </a:pPr>
-            <a:r>
-              <a:rPr lang="en-US" sz="1300" b="1" dirty="0">
+          <p:cNvPr id="6" name="Text 4"/>
+          <p:cNvSpPr txBox="1"/>
+          <p:nvPr/>
+        </p:nvSpPr>
+        <p:spPr>
+          <a:xfrm>
+            <a:off x="731520" y="1371600"/>
+            <a:ext cx="7680960" cy="1554480"/>
+          </a:xfrm>
+          <a:prstGeom prst="rect">
+            <a:avLst/>
+          </a:prstGeom>
+          <a:noFill/>
+          <a:ln/>
+        </p:spPr>
+        <p:txBody>
+          <a:bodyPr wrap="square" lIns="0" tIns="0" rIns="0" bIns="0" rtlCol="0" anchor="ctr"/>
+          <a:lstStyle/>
+          <a:p>
+            <a:pPr indent="0" marL="0">
+              <a:buNone/>
+            </a:pPr>
+            <a:r>
+              <a:rPr lang="en-US" sz="1700" i="1" dirty="0">
                 <a:solidFill>
                   <a:srgbClr val="2B2318"/>
                 </a:solidFill>
@@ -3954,324 +3609,26 @@
                 <a:ea typeface="Calibri" pitchFamily="34" charset="-122"/>
                 <a:cs typeface="Calibri" pitchFamily="34" charset="-120"/>
               </a:rPr>
-              <a:t>schwarz: </a:t>
-            </a:r>
-            <a:pPr indent="0" marL="0">
-              <a:buNone/>
-            </a:pPr>
-            <a:r>
-              <a:rPr lang="en-US" sz="1300" dirty="0">
-                <a:solidFill>
-                  <a:srgbClr val="2B2318"/>
-                </a:solidFill>
-                <a:latin typeface="Calibri" pitchFamily="34" charset="0"/>
-                <a:ea typeface="Calibri" pitchFamily="34" charset="-122"/>
-                <a:cs typeface="Calibri" pitchFamily="34" charset="-120"/>
-              </a:rPr>
-              <a:t>Peisistratos fördert die Gruppen mit Maßnahmen.
-</a:t>
-            </a:r>
-            <a:pPr indent="0" marL="0">
-              <a:buNone/>
-            </a:pPr>
-            <a:r>
-              <a:rPr lang="en-US" sz="1300" b="1" dirty="0">
-                <a:solidFill>
-                  <a:srgbClr val="AA7820"/>
-                </a:solidFill>
-                <a:latin typeface="Calibri" pitchFamily="34" charset="0"/>
-                <a:ea typeface="Calibri" pitchFamily="34" charset="-122"/>
-                <a:cs typeface="Calibri" pitchFamily="34" charset="-120"/>
-              </a:rPr>
-              <a:t>gold: </a:t>
-            </a:r>
-            <a:pPr indent="0" marL="0">
-              <a:buNone/>
-            </a:pPr>
-            <a:r>
-              <a:rPr lang="en-US" sz="1300" dirty="0">
-                <a:solidFill>
-                  <a:srgbClr val="2B2318"/>
-                </a:solidFill>
-                <a:latin typeface="Calibri" pitchFamily="34" charset="0"/>
-                <a:ea typeface="Calibri" pitchFamily="34" charset="-122"/>
-                <a:cs typeface="Calibri" pitchFamily="34" charset="-120"/>
-              </a:rPr>
-              <a:t>Die Gruppen unterstützen ihn dafür.
-</a:t>
-            </a:r>
-            <a:pPr indent="0" marL="0">
-              <a:buNone/>
-            </a:pPr>
-            <a:r>
-              <a:rPr lang="en-US" sz="1300" b="1" dirty="0">
-                <a:solidFill>
-                  <a:srgbClr val="AD4426"/>
-                </a:solidFill>
-                <a:latin typeface="Calibri" pitchFamily="34" charset="0"/>
-                <a:ea typeface="Calibri" pitchFamily="34" charset="-122"/>
-                <a:cs typeface="Calibri" pitchFamily="34" charset="-120"/>
-              </a:rPr>
-              <a:t>So sichert er seine Macht.</a:t>
-            </a:r>
-            <a:endParaRPr lang="en-US" sz="1300" dirty="0"/>
-          </a:p>
-        </p:txBody>
-      </p:sp>
-      <p:sp>
-        <p:nvSpPr>
-          <p:cNvPr id="9" name="Text 6"/>
-          <p:cNvSpPr txBox="1"/>
-          <p:nvPr/>
-        </p:nvSpPr>
-        <p:spPr>
-          <a:xfrm>
-            <a:off x="457200" y="4754880"/>
-            <a:ext cx="5486400" cy="182880"/>
-          </a:xfrm>
-          <a:prstGeom prst="rect">
-            <a:avLst/>
-          </a:prstGeom>
-          <a:noFill/>
-          <a:ln/>
-        </p:spPr>
-        <p:txBody>
-          <a:bodyPr wrap="square" lIns="0" tIns="0" rIns="0" bIns="0" rtlCol="0" anchor="t"/>
-          <a:lstStyle/>
-          <a:p>
-            <a:pPr indent="0" marL="0">
-              <a:buNone/>
-            </a:pPr>
-            <a:r>
-              <a:rPr lang="en-US" sz="900" dirty="0">
-                <a:solidFill>
-                  <a:srgbClr val="998C77"/>
-                </a:solidFill>
-                <a:latin typeface="Calibri" pitchFamily="34" charset="0"/>
-                <a:ea typeface="Calibri" pitchFamily="34" charset="-122"/>
-                <a:cs typeface="Calibri" pitchFamily="34" charset="-120"/>
-              </a:rPr>
-              <a:t>Peisistratos – ein Tyrann als Wegbereiter?</a:t>
-            </a:r>
-            <a:endParaRPr lang="en-US" sz="900" dirty="0"/>
-          </a:p>
-        </p:txBody>
-      </p:sp>
-      <p:sp>
-        <p:nvSpPr>
-          <p:cNvPr id="25" name="Slide Number Placeholder 0"/>
-          <p:cNvSpPr>
-            <a:spLocks noGrp="1"/>
-          </p:cNvSpPr>
-          <p:nvPr>
-            <p:ph type="sldNum" sz="quarter" idx="4294967295"/>
-          </p:nvPr>
-        </p:nvSpPr>
-        <p:spPr>
-          <a:xfrm>
-            <a:off x="8229600" y="4727448"/>
-            <a:ext cx="457200" cy="228600"/>
-          </a:xfrm>
-          <a:prstGeom prst="rect">
-            <a:avLst/>
-          </a:prstGeom>
-          <a:extLst>
-            <a:ext uri="{C572A759-6A51-4108-AA02-DFA0A04FC94B}">
-              <ma14:wrappingTextBoxFlag xmlns:ma14="http://schemas.microsoft.com/office/mac/drawingml/2011/main" val="0"/>
-            </a:ext>
-          </a:extLst>
-        </p:spPr>
-        <p:txBody>
-          <a:bodyPr/>
-          <a:lstStyle>
-            <a:lvl1pPr>
-              <a:defRPr sz="900">
-                <a:solidFill>
-                  <a:srgbClr val="998C77"/>
-                </a:solidFill>
-                <a:latin typeface="Calibri"/>
-                <a:ea typeface="Calibri"/>
-                <a:cs typeface="Calibri"/>
-              </a:defRPr>
-            </a:lvl1pPr>
-          </a:lstStyle>
-          <a:p>
-            <a:pPr algn="r"/>
-            <a:fld id="{F7021451-1387-4CA6-816F-3879F97B5CBC}" type="slidenum">
-              <a:rPr b="0" lang="en-US"/>
-              <a:t>12</a:t>
-            </a:fld>
-            <a:endParaRPr lang="en-US"/>
-          </a:p>
-        </p:txBody>
-      </p:sp>
-    </p:spTree>
-  </p:cSld>
-  <p:clrMapOvr>
-    <a:masterClrMapping/>
-  </p:clrMapOvr>
-</p:sld>
-</file>
-
-<file path=ppt/slides/slide13.xml><?xml version="1.0" encoding="utf-8"?>
-<p:sld xmlns:a="http://schemas.openxmlformats.org/drawingml/2006/main" xmlns:r="http://schemas.openxmlformats.org/officeDocument/2006/relationships" xmlns:p="http://schemas.openxmlformats.org/presentationml/2006/main">
-  <p:cSld name="Slide 13">
-    <p:bg>
-      <p:bgPr>
-        <a:solidFill>
-          <a:srgbClr val="FFFFFF"/>
-        </a:solidFill>
-      </p:bgPr>
-    </p:bg>
-    <p:spTree>
-      <p:nvGrpSpPr>
-        <p:cNvPr id="1" name=""/>
-        <p:cNvGrpSpPr/>
-        <p:nvPr/>
-      </p:nvGrpSpPr>
-      <p:grpSpPr>
-        <a:xfrm>
-          <a:off x="0" y="0"/>
-          <a:ext cx="0" cy="0"/>
-          <a:chOff x="0" y="0"/>
-          <a:chExt cx="0" cy="0"/>
-        </a:xfrm>
-      </p:grpSpPr>
-      <p:sp>
-        <p:nvSpPr>
-          <p:cNvPr id="2" name="Text 0"/>
-          <p:cNvSpPr txBox="1"/>
-          <p:nvPr/>
-        </p:nvSpPr>
-        <p:spPr>
-          <a:xfrm>
-            <a:off x="457200" y="320040"/>
-            <a:ext cx="6766560" cy="228600"/>
-          </a:xfrm>
-          <a:prstGeom prst="rect">
-            <a:avLst/>
-          </a:prstGeom>
-          <a:noFill/>
-          <a:ln/>
-        </p:spPr>
-        <p:txBody>
-          <a:bodyPr wrap="square" lIns="0" tIns="0" rIns="0" bIns="0" rtlCol="0" anchor="t"/>
-          <a:lstStyle/>
-          <a:p>
-            <a:pPr indent="0" marL="0">
-              <a:buNone/>
-            </a:pPr>
-            <a:r>
-              <a:rPr lang="en-US" sz="1100" b="1" spc="200" kern="0" dirty="0">
-                <a:solidFill>
-                  <a:srgbClr val="AD4426"/>
-                </a:solidFill>
-                <a:latin typeface="Calibri" pitchFamily="34" charset="0"/>
-                <a:ea typeface="Calibri" pitchFamily="34" charset="-122"/>
-                <a:cs typeface="Calibri" pitchFamily="34" charset="-120"/>
-              </a:rPr>
-              <a:t>EINZELARBEIT · ZETTEL</a:t>
-            </a:r>
-            <a:endParaRPr lang="en-US" sz="1100" dirty="0"/>
-          </a:p>
-        </p:txBody>
-      </p:sp>
-      <p:sp>
-        <p:nvSpPr>
-          <p:cNvPr id="3" name="Text 1"/>
-          <p:cNvSpPr txBox="1"/>
-          <p:nvPr/>
-        </p:nvSpPr>
-        <p:spPr>
-          <a:xfrm>
-            <a:off x="457200" y="548640"/>
-            <a:ext cx="8229600" cy="594360"/>
-          </a:xfrm>
-          <a:prstGeom prst="rect">
-            <a:avLst/>
-          </a:prstGeom>
-          <a:noFill/>
-          <a:ln/>
-        </p:spPr>
-        <p:txBody>
-          <a:bodyPr wrap="square" lIns="0" tIns="0" rIns="0" bIns="0" rtlCol="0" anchor="t"/>
-          <a:lstStyle/>
-          <a:p>
-            <a:pPr indent="0" marL="0">
-              <a:buNone/>
-            </a:pPr>
-            <a:r>
-              <a:rPr lang="en-US" sz="2800" b="1" dirty="0">
-                <a:solidFill>
-                  <a:srgbClr val="2B2318"/>
-                </a:solidFill>
-                <a:latin typeface="Cambria" pitchFamily="34" charset="0"/>
-                <a:ea typeface="Cambria" pitchFamily="34" charset="-122"/>
-                <a:cs typeface="Cambria" pitchFamily="34" charset="-120"/>
-              </a:rPr>
-              <a:t>Ausgangskarte</a:t>
-            </a:r>
-            <a:endParaRPr lang="en-US" sz="2800" dirty="0"/>
-          </a:p>
-        </p:txBody>
-      </p:sp>
-      <p:sp>
-        <p:nvSpPr>
-          <p:cNvPr id="4" name="Text 2"/>
-          <p:cNvSpPr txBox="1"/>
-          <p:nvPr/>
-        </p:nvSpPr>
-        <p:spPr>
-          <a:xfrm>
-            <a:off x="7315200" y="347472"/>
-            <a:ext cx="1371600" cy="292608"/>
+              <a:t>„Peisistratos war ein Tyrann, aber er brachte Athen der Demokratie näher, weil er die Bauern und den Mittelstand stärkte – zum Beispiel durch Land und Kredite – und so ihre Abhängigkeit vom Adel verringerte.“</a:t>
+            </a:r>
+            <a:endParaRPr lang="en-US" sz="1700" dirty="0"/>
+          </a:p>
+        </p:txBody>
+      </p:sp>
+      <p:sp>
+        <p:nvSpPr>
+          <p:cNvPr id="7" name="Shape 5"/>
+          <p:cNvSpPr/>
+          <p:nvPr/>
+        </p:nvSpPr>
+        <p:spPr>
+          <a:xfrm>
+            <a:off x="457200" y="3246120"/>
+            <a:ext cx="8229600" cy="731520"/>
           </a:xfrm>
           <a:prstGeom prst="roundRect">
             <a:avLst>
-              <a:gd name="adj" fmla="val 31250"/>
-            </a:avLst>
-          </a:prstGeom>
-          <a:solidFill>
-            <a:srgbClr val="2B2318"/>
-          </a:solidFill>
-          <a:ln/>
-        </p:spPr>
-        <p:txBody>
-          <a:bodyPr wrap="square" lIns="25400" tIns="25400" rIns="25400" bIns="25400" rtlCol="0" anchor="ctr"/>
-          <a:lstStyle/>
-          <a:p>
-            <a:pPr algn="ctr" indent="0" marL="0">
-              <a:buNone/>
-            </a:pPr>
-            <a:r>
-              <a:rPr lang="en-US" sz="1100" b="1" dirty="0">
-                <a:solidFill>
-                  <a:srgbClr val="FFFFFF"/>
-                </a:solidFill>
-                <a:latin typeface="Calibri" pitchFamily="34" charset="0"/>
-                <a:ea typeface="Calibri" pitchFamily="34" charset="-122"/>
-                <a:cs typeface="Calibri" pitchFamily="34" charset="-120"/>
-              </a:rPr>
-              <a:t>4 Min.</a:t>
-            </a:r>
-            <a:endParaRPr lang="en-US" sz="1100" dirty="0"/>
-          </a:p>
-        </p:txBody>
-      </p:sp>
-      <p:sp>
-        <p:nvSpPr>
-          <p:cNvPr id="5" name="Shape 3"/>
-          <p:cNvSpPr/>
-          <p:nvPr/>
-        </p:nvSpPr>
-        <p:spPr>
-          <a:xfrm>
-            <a:off x="457200" y="1371600"/>
-            <a:ext cx="8229600" cy="1280160"/>
-          </a:xfrm>
-          <a:prstGeom prst="roundRect">
-            <a:avLst>
-              <a:gd name="adj" fmla="val 5714"/>
+              <a:gd name="adj" fmla="val 10000"/>
             </a:avLst>
           </a:prstGeom>
           <a:solidFill>
@@ -4287,14 +3644,14 @@
       </p:sp>
       <p:sp>
         <p:nvSpPr>
-          <p:cNvPr id="6" name="Text 4"/>
-          <p:cNvSpPr txBox="1"/>
-          <p:nvPr/>
-        </p:nvSpPr>
-        <p:spPr>
-          <a:xfrm>
-            <a:off x="731520" y="1371600"/>
-            <a:ext cx="7680960" cy="1280160"/>
+          <p:cNvPr id="8" name="Text 6"/>
+          <p:cNvSpPr txBox="1"/>
+          <p:nvPr/>
+        </p:nvSpPr>
+        <p:spPr>
+          <a:xfrm>
+            <a:off x="731520" y="3246120"/>
+            <a:ext cx="7680960" cy="731520"/>
           </a:xfrm>
           <a:prstGeom prst="rect">
             <a:avLst/>
@@ -4310,263 +3667,23 @@
               <a:buNone/>
             </a:pPr>
             <a:r>
-              <a:rPr lang="en-US" sz="2600" b="1" dirty="0">
-                <a:solidFill>
-                  <a:srgbClr val="FFFFFF"/>
-                </a:solidFill>
-                <a:latin typeface="Cambria" pitchFamily="34" charset="0"/>
-                <a:ea typeface="Cambria" pitchFamily="34" charset="-122"/>
-                <a:cs typeface="Cambria" pitchFamily="34" charset="-120"/>
-              </a:rPr>
-              <a:t>„Peisistratos war ein Tyrann, aber …, weil …“</a:t>
-            </a:r>
-            <a:endParaRPr lang="en-US" sz="2600" dirty="0"/>
-          </a:p>
-        </p:txBody>
-      </p:sp>
-      <p:sp>
-        <p:nvSpPr>
-          <p:cNvPr id="7" name="Text 5"/>
-          <p:cNvSpPr txBox="1"/>
-          <p:nvPr/>
-        </p:nvSpPr>
-        <p:spPr>
-          <a:xfrm>
-            <a:off x="457200" y="2926080"/>
-            <a:ext cx="365760" cy="365760"/>
-          </a:xfrm>
-          <a:prstGeom prst="ellipse">
-            <a:avLst/>
-          </a:prstGeom>
-          <a:solidFill>
-            <a:srgbClr val="AD4426"/>
-          </a:solidFill>
-          <a:ln/>
-        </p:spPr>
-        <p:txBody>
-          <a:bodyPr wrap="square" lIns="0" tIns="0" rIns="0" bIns="0" rtlCol="0" anchor="ctr"/>
-          <a:lstStyle/>
-          <a:p>
-            <a:pPr algn="ctr" indent="0" marL="0">
-              <a:buNone/>
-            </a:pPr>
-            <a:r>
-              <a:rPr lang="en-US" sz="1400" b="1" dirty="0">
-                <a:solidFill>
-                  <a:srgbClr val="FFFFFF"/>
-                </a:solidFill>
-                <a:latin typeface="Cambria" pitchFamily="34" charset="0"/>
-                <a:ea typeface="Cambria" pitchFamily="34" charset="-122"/>
-                <a:cs typeface="Cambria" pitchFamily="34" charset="-120"/>
-              </a:rPr>
-              <a:t>1</a:t>
-            </a:r>
-            <a:endParaRPr lang="en-US" sz="1400" dirty="0"/>
-          </a:p>
-        </p:txBody>
-      </p:sp>
-      <p:sp>
-        <p:nvSpPr>
-          <p:cNvPr id="8" name="Text 6"/>
-          <p:cNvSpPr txBox="1"/>
-          <p:nvPr/>
-        </p:nvSpPr>
-        <p:spPr>
-          <a:xfrm>
-            <a:off x="960120" y="2889504"/>
-            <a:ext cx="7726680" cy="493776"/>
-          </a:xfrm>
-          <a:prstGeom prst="rect">
-            <a:avLst/>
-          </a:prstGeom>
-          <a:noFill/>
-          <a:ln/>
-        </p:spPr>
-        <p:txBody>
-          <a:bodyPr wrap="square" lIns="0" tIns="0" rIns="0" bIns="0" rtlCol="0" anchor="ctr"/>
-          <a:lstStyle/>
-          <a:p>
-            <a:pPr indent="0" marL="0">
-              <a:buNone/>
-            </a:pPr>
-            <a:r>
-              <a:rPr lang="en-US" sz="1400" dirty="0">
-                <a:solidFill>
-                  <a:srgbClr val="2B2318"/>
-                </a:solidFill>
-                <a:latin typeface="Calibri" pitchFamily="34" charset="0"/>
-                <a:ea typeface="Calibri" pitchFamily="34" charset="-122"/>
-                <a:cs typeface="Calibri" pitchFamily="34" charset="-120"/>
-              </a:rPr>
-              <a:t>Ergänze den Satz auf einem Zettel mit Namen.</a:t>
-            </a:r>
-            <a:endParaRPr lang="en-US" sz="1400" dirty="0"/>
+              <a:rPr lang="en-US" sz="1600" b="1" dirty="0">
+                <a:solidFill>
+                  <a:srgbClr val="D9A441"/>
+                </a:solidFill>
+                <a:latin typeface="Calibri" pitchFamily="34" charset="0"/>
+                <a:ea typeface="Calibri" pitchFamily="34" charset="-122"/>
+                <a:cs typeface="Calibri" pitchFamily="34" charset="-120"/>
+              </a:rPr>
+              <a:t>Ausblick: Wie wird aus Athen eine echte Demokratie? → Kleisthenes</a:t>
+            </a:r>
+            <a:endParaRPr lang="en-US" sz="1600" dirty="0"/>
           </a:p>
         </p:txBody>
       </p:sp>
       <p:sp>
         <p:nvSpPr>
           <p:cNvPr id="9" name="Text 7"/>
-          <p:cNvSpPr txBox="1"/>
-          <p:nvPr/>
-        </p:nvSpPr>
-        <p:spPr>
-          <a:xfrm>
-            <a:off x="457200" y="3456432"/>
-            <a:ext cx="365760" cy="365760"/>
-          </a:xfrm>
-          <a:prstGeom prst="ellipse">
-            <a:avLst/>
-          </a:prstGeom>
-          <a:solidFill>
-            <a:srgbClr val="AD4426"/>
-          </a:solidFill>
-          <a:ln/>
-        </p:spPr>
-        <p:txBody>
-          <a:bodyPr wrap="square" lIns="0" tIns="0" rIns="0" bIns="0" rtlCol="0" anchor="ctr"/>
-          <a:lstStyle/>
-          <a:p>
-            <a:pPr algn="ctr" indent="0" marL="0">
-              <a:buNone/>
-            </a:pPr>
-            <a:r>
-              <a:rPr lang="en-US" sz="1400" b="1" dirty="0">
-                <a:solidFill>
-                  <a:srgbClr val="FFFFFF"/>
-                </a:solidFill>
-                <a:latin typeface="Cambria" pitchFamily="34" charset="0"/>
-                <a:ea typeface="Cambria" pitchFamily="34" charset="-122"/>
-                <a:cs typeface="Cambria" pitchFamily="34" charset="-120"/>
-              </a:rPr>
-              <a:t>2</a:t>
-            </a:r>
-            <a:endParaRPr lang="en-US" sz="1400" dirty="0"/>
-          </a:p>
-        </p:txBody>
-      </p:sp>
-      <p:sp>
-        <p:nvSpPr>
-          <p:cNvPr id="10" name="Text 8"/>
-          <p:cNvSpPr txBox="1"/>
-          <p:nvPr/>
-        </p:nvSpPr>
-        <p:spPr>
-          <a:xfrm>
-            <a:off x="960120" y="3419856"/>
-            <a:ext cx="7726680" cy="493776"/>
-          </a:xfrm>
-          <a:prstGeom prst="rect">
-            <a:avLst/>
-          </a:prstGeom>
-          <a:noFill/>
-          <a:ln/>
-        </p:spPr>
-        <p:txBody>
-          <a:bodyPr wrap="square" lIns="0" tIns="0" rIns="0" bIns="0" rtlCol="0" anchor="ctr"/>
-          <a:lstStyle/>
-          <a:p>
-            <a:pPr indent="0" marL="0">
-              <a:buNone/>
-            </a:pPr>
-            <a:r>
-              <a:rPr lang="en-US" sz="1400" dirty="0">
-                <a:solidFill>
-                  <a:srgbClr val="2B2318"/>
-                </a:solidFill>
-                <a:latin typeface="Calibri" pitchFamily="34" charset="0"/>
-                <a:ea typeface="Calibri" pitchFamily="34" charset="-122"/>
-                <a:cs typeface="Calibri" pitchFamily="34" charset="-120"/>
-              </a:rPr>
-              <a:t>Nenne mindestens eine Maßnahme als Beleg.</a:t>
-            </a:r>
-            <a:endParaRPr lang="en-US" sz="1400" dirty="0"/>
-          </a:p>
-        </p:txBody>
-      </p:sp>
-      <p:sp>
-        <p:nvSpPr>
-          <p:cNvPr id="11" name="Text 9"/>
-          <p:cNvSpPr txBox="1"/>
-          <p:nvPr/>
-        </p:nvSpPr>
-        <p:spPr>
-          <a:xfrm>
-            <a:off x="457200" y="3986784"/>
-            <a:ext cx="365760" cy="365760"/>
-          </a:xfrm>
-          <a:prstGeom prst="ellipse">
-            <a:avLst/>
-          </a:prstGeom>
-          <a:solidFill>
-            <a:srgbClr val="AD4426"/>
-          </a:solidFill>
-          <a:ln/>
-        </p:spPr>
-        <p:txBody>
-          <a:bodyPr wrap="square" lIns="0" tIns="0" rIns="0" bIns="0" rtlCol="0" anchor="ctr"/>
-          <a:lstStyle/>
-          <a:p>
-            <a:pPr algn="ctr" indent="0" marL="0">
-              <a:buNone/>
-            </a:pPr>
-            <a:r>
-              <a:rPr lang="en-US" sz="1400" b="1" dirty="0">
-                <a:solidFill>
-                  <a:srgbClr val="FFFFFF"/>
-                </a:solidFill>
-                <a:latin typeface="Cambria" pitchFamily="34" charset="0"/>
-                <a:ea typeface="Cambria" pitchFamily="34" charset="-122"/>
-                <a:cs typeface="Cambria" pitchFamily="34" charset="-120"/>
-              </a:rPr>
-              <a:t>3</a:t>
-            </a:r>
-            <a:endParaRPr lang="en-US" sz="1400" dirty="0"/>
-          </a:p>
-        </p:txBody>
-      </p:sp>
-      <p:sp>
-        <p:nvSpPr>
-          <p:cNvPr id="12" name="Text 10"/>
-          <p:cNvSpPr txBox="1"/>
-          <p:nvPr/>
-        </p:nvSpPr>
-        <p:spPr>
-          <a:xfrm>
-            <a:off x="960120" y="3950208"/>
-            <a:ext cx="7726680" cy="493776"/>
-          </a:xfrm>
-          <a:prstGeom prst="rect">
-            <a:avLst/>
-          </a:prstGeom>
-          <a:noFill/>
-          <a:ln/>
-        </p:spPr>
-        <p:txBody>
-          <a:bodyPr wrap="square" lIns="0" tIns="0" rIns="0" bIns="0" rtlCol="0" anchor="ctr"/>
-          <a:lstStyle/>
-          <a:p>
-            <a:pPr indent="0" marL="0">
-              <a:buNone/>
-            </a:pPr>
-            <a:r>
-              <a:rPr lang="en-US" sz="1400" dirty="0">
-                <a:solidFill>
-                  <a:srgbClr val="2B2318"/>
-                </a:solidFill>
-                <a:latin typeface="Calibri" pitchFamily="34" charset="0"/>
-                <a:ea typeface="Calibri" pitchFamily="34" charset="-122"/>
-                <a:cs typeface="Calibri" pitchFamily="34" charset="-120"/>
-              </a:rPr>
-              <a:t>Gib den Zettel beim Rausgehen ab.</a:t>
-            </a:r>
-            <a:endParaRPr lang="en-US" sz="1400" dirty="0"/>
-          </a:p>
-        </p:txBody>
-      </p:sp>
-      <p:sp>
-        <p:nvSpPr>
-          <p:cNvPr id="13" name="Text 11"/>
           <p:cNvSpPr txBox="1"/>
           <p:nvPr/>
         </p:nvSpPr>
@@ -4645,379 +3762,7 @@
             <a:pPr algn="r"/>
             <a:fld id="{F7021451-1387-4CA6-816F-3879F97B5CBC}" type="slidenum">
               <a:rPr b="0" lang="en-US"/>
-              <a:t>13</a:t>
-            </a:fld>
-            <a:endParaRPr lang="en-US"/>
-          </a:p>
-        </p:txBody>
-      </p:sp>
-    </p:spTree>
-  </p:cSld>
-  <p:clrMapOvr>
-    <a:masterClrMapping/>
-  </p:clrMapOvr>
-</p:sld>
-</file>
-
-<file path=ppt/slides/slide14.xml><?xml version="1.0" encoding="utf-8"?>
-<p:sld xmlns:a="http://schemas.openxmlformats.org/drawingml/2006/main" xmlns:r="http://schemas.openxmlformats.org/officeDocument/2006/relationships" xmlns:p="http://schemas.openxmlformats.org/presentationml/2006/main">
-  <p:cSld name="Slide 14">
-    <p:bg>
-      <p:bgPr>
-        <a:solidFill>
-          <a:srgbClr val="FFFFFF"/>
-        </a:solidFill>
-      </p:bgPr>
-    </p:bg>
-    <p:spTree>
-      <p:nvGrpSpPr>
-        <p:cNvPr id="1" name=""/>
-        <p:cNvGrpSpPr/>
-        <p:nvPr/>
-      </p:nvGrpSpPr>
-      <p:grpSpPr>
-        <a:xfrm>
-          <a:off x="0" y="0"/>
-          <a:ext cx="0" cy="0"/>
-          <a:chOff x="0" y="0"/>
-          <a:chExt cx="0" cy="0"/>
-        </a:xfrm>
-      </p:grpSpPr>
-      <p:sp>
-        <p:nvSpPr>
-          <p:cNvPr id="2" name="Text 0"/>
-          <p:cNvSpPr txBox="1"/>
-          <p:nvPr/>
-        </p:nvSpPr>
-        <p:spPr>
-          <a:xfrm>
-            <a:off x="457200" y="320040"/>
-            <a:ext cx="6766560" cy="228600"/>
-          </a:xfrm>
-          <a:prstGeom prst="rect">
-            <a:avLst/>
-          </a:prstGeom>
-          <a:noFill/>
-          <a:ln/>
-        </p:spPr>
-        <p:txBody>
-          <a:bodyPr wrap="square" lIns="0" tIns="0" rIns="0" bIns="0" rtlCol="0" anchor="t"/>
-          <a:lstStyle/>
-          <a:p>
-            <a:pPr indent="0" marL="0">
-              <a:buNone/>
-            </a:pPr>
-            <a:r>
-              <a:rPr lang="en-US" sz="1100" b="1" spc="200" kern="0" dirty="0">
-                <a:solidFill>
-                  <a:srgbClr val="AD4426"/>
-                </a:solidFill>
-                <a:latin typeface="Calibri" pitchFamily="34" charset="0"/>
-                <a:ea typeface="Calibri" pitchFamily="34" charset="-122"/>
-                <a:cs typeface="Calibri" pitchFamily="34" charset="-120"/>
-              </a:rPr>
-              <a:t>AUSGANGSKARTE · BEISPIEL</a:t>
-            </a:r>
-            <a:endParaRPr lang="en-US" sz="1100" dirty="0"/>
-          </a:p>
-        </p:txBody>
-      </p:sp>
-      <p:sp>
-        <p:nvSpPr>
-          <p:cNvPr id="3" name="Text 1"/>
-          <p:cNvSpPr txBox="1"/>
-          <p:nvPr/>
-        </p:nvSpPr>
-        <p:spPr>
-          <a:xfrm>
-            <a:off x="457200" y="548640"/>
-            <a:ext cx="8229600" cy="594360"/>
-          </a:xfrm>
-          <a:prstGeom prst="rect">
-            <a:avLst/>
-          </a:prstGeom>
-          <a:noFill/>
-          <a:ln/>
-        </p:spPr>
-        <p:txBody>
-          <a:bodyPr wrap="square" lIns="0" tIns="0" rIns="0" bIns="0" rtlCol="0" anchor="t"/>
-          <a:lstStyle/>
-          <a:p>
-            <a:pPr indent="0" marL="0">
-              <a:buNone/>
-            </a:pPr>
-            <a:r>
-              <a:rPr lang="en-US" sz="2800" b="1" dirty="0">
-                <a:solidFill>
-                  <a:srgbClr val="2B2318"/>
-                </a:solidFill>
-                <a:latin typeface="Cambria" pitchFamily="34" charset="0"/>
-                <a:ea typeface="Cambria" pitchFamily="34" charset="-122"/>
-                <a:cs typeface="Cambria" pitchFamily="34" charset="-120"/>
-              </a:rPr>
-              <a:t>So könnte dein Satz lauten</a:t>
-            </a:r>
-            <a:endParaRPr lang="en-US" sz="2800" dirty="0"/>
-          </a:p>
-        </p:txBody>
-      </p:sp>
-      <p:sp>
-        <p:nvSpPr>
-          <p:cNvPr id="4" name="Text 2"/>
-          <p:cNvSpPr txBox="1"/>
-          <p:nvPr/>
-        </p:nvSpPr>
-        <p:spPr>
-          <a:xfrm>
-            <a:off x="7315200" y="347472"/>
-            <a:ext cx="1371600" cy="292608"/>
-          </a:xfrm>
-          <a:prstGeom prst="roundRect">
-            <a:avLst>
-              <a:gd name="adj" fmla="val 31250"/>
-            </a:avLst>
-          </a:prstGeom>
-          <a:solidFill>
-            <a:srgbClr val="D9A441"/>
-          </a:solidFill>
-          <a:ln/>
-        </p:spPr>
-        <p:txBody>
-          <a:bodyPr wrap="square" lIns="25400" tIns="25400" rIns="25400" bIns="25400" rtlCol="0" anchor="ctr"/>
-          <a:lstStyle/>
-          <a:p>
-            <a:pPr algn="ctr" indent="0" marL="0">
-              <a:buNone/>
-            </a:pPr>
-            <a:r>
-              <a:rPr lang="en-US" sz="1100" b="1" dirty="0">
-                <a:solidFill>
-                  <a:srgbClr val="2B2318"/>
-                </a:solidFill>
-                <a:latin typeface="Calibri" pitchFamily="34" charset="0"/>
-                <a:ea typeface="Calibri" pitchFamily="34" charset="-122"/>
-                <a:cs typeface="Calibri" pitchFamily="34" charset="-120"/>
-              </a:rPr>
-              <a:t>Lösung</a:t>
-            </a:r>
-            <a:endParaRPr lang="en-US" sz="1100" dirty="0"/>
-          </a:p>
-        </p:txBody>
-      </p:sp>
-      <p:sp>
-        <p:nvSpPr>
-          <p:cNvPr id="5" name="Shape 3"/>
-          <p:cNvSpPr/>
-          <p:nvPr/>
-        </p:nvSpPr>
-        <p:spPr>
-          <a:xfrm>
-            <a:off x="457200" y="1280160"/>
-            <a:ext cx="8229600" cy="1737360"/>
-          </a:xfrm>
-          <a:prstGeom prst="roundRect">
-            <a:avLst>
-              <a:gd name="adj" fmla="val 4211"/>
-            </a:avLst>
-          </a:prstGeom>
-          <a:solidFill>
-            <a:srgbClr val="F4ECDE"/>
-          </a:solidFill>
-          <a:ln w="12700">
-            <a:solidFill>
-              <a:srgbClr val="F4ECDE"/>
-            </a:solidFill>
-            <a:prstDash val="solid"/>
-          </a:ln>
-        </p:spPr>
-      </p:sp>
-      <p:sp>
-        <p:nvSpPr>
-          <p:cNvPr id="6" name="Text 4"/>
-          <p:cNvSpPr txBox="1"/>
-          <p:nvPr/>
-        </p:nvSpPr>
-        <p:spPr>
-          <a:xfrm>
-            <a:off x="731520" y="1371600"/>
-            <a:ext cx="7680960" cy="1554480"/>
-          </a:xfrm>
-          <a:prstGeom prst="rect">
-            <a:avLst/>
-          </a:prstGeom>
-          <a:noFill/>
-          <a:ln/>
-        </p:spPr>
-        <p:txBody>
-          <a:bodyPr wrap="square" lIns="0" tIns="0" rIns="0" bIns="0" rtlCol="0" anchor="ctr"/>
-          <a:lstStyle/>
-          <a:p>
-            <a:pPr indent="0" marL="0">
-              <a:buNone/>
-            </a:pPr>
-            <a:r>
-              <a:rPr lang="en-US" sz="1700" i="1" dirty="0">
-                <a:solidFill>
-                  <a:srgbClr val="2B2318"/>
-                </a:solidFill>
-                <a:latin typeface="Calibri" pitchFamily="34" charset="0"/>
-                <a:ea typeface="Calibri" pitchFamily="34" charset="-122"/>
-                <a:cs typeface="Calibri" pitchFamily="34" charset="-120"/>
-              </a:rPr>
-              <a:t>„Peisistratos war ein Tyrann, aber er brachte Athen der Demokratie näher, weil er die Bauern und den Mittelstand stärkte – zum Beispiel durch Land und Kredite – und so ihre Abhängigkeit vom Adel verringerte.“</a:t>
-            </a:r>
-            <a:endParaRPr lang="en-US" sz="1700" dirty="0"/>
-          </a:p>
-        </p:txBody>
-      </p:sp>
-      <p:sp>
-        <p:nvSpPr>
-          <p:cNvPr id="7" name="Shape 5"/>
-          <p:cNvSpPr/>
-          <p:nvPr/>
-        </p:nvSpPr>
-        <p:spPr>
-          <a:xfrm>
-            <a:off x="457200" y="3246120"/>
-            <a:ext cx="8229600" cy="731520"/>
-          </a:xfrm>
-          <a:prstGeom prst="roundRect">
-            <a:avLst>
-              <a:gd name="adj" fmla="val 10000"/>
-            </a:avLst>
-          </a:prstGeom>
-          <a:solidFill>
-            <a:srgbClr val="2B2318"/>
-          </a:solidFill>
-          <a:ln w="12700">
-            <a:solidFill>
-              <a:srgbClr val="2B2318"/>
-            </a:solidFill>
-            <a:prstDash val="solid"/>
-          </a:ln>
-        </p:spPr>
-      </p:sp>
-      <p:sp>
-        <p:nvSpPr>
-          <p:cNvPr id="8" name="Text 6"/>
-          <p:cNvSpPr txBox="1"/>
-          <p:nvPr/>
-        </p:nvSpPr>
-        <p:spPr>
-          <a:xfrm>
-            <a:off x="731520" y="3246120"/>
-            <a:ext cx="7680960" cy="731520"/>
-          </a:xfrm>
-          <a:prstGeom prst="rect">
-            <a:avLst/>
-          </a:prstGeom>
-          <a:noFill/>
-          <a:ln/>
-        </p:spPr>
-        <p:txBody>
-          <a:bodyPr wrap="square" lIns="0" tIns="0" rIns="0" bIns="0" rtlCol="0" anchor="ctr"/>
-          <a:lstStyle/>
-          <a:p>
-            <a:pPr indent="0" marL="0">
-              <a:buNone/>
-            </a:pPr>
-            <a:r>
-              <a:rPr lang="en-US" sz="1600" b="1" dirty="0">
-                <a:solidFill>
-                  <a:srgbClr val="D9A441"/>
-                </a:solidFill>
-                <a:latin typeface="Calibri" pitchFamily="34" charset="0"/>
-                <a:ea typeface="Calibri" pitchFamily="34" charset="-122"/>
-                <a:cs typeface="Calibri" pitchFamily="34" charset="-120"/>
-              </a:rPr>
-              <a:t>Ausblick: Wie wird aus Athen eine echte Demokratie? → Kleisthenes</a:t>
-            </a:r>
-            <a:endParaRPr lang="en-US" sz="1600" dirty="0"/>
-          </a:p>
-        </p:txBody>
-      </p:sp>
-      <p:sp>
-        <p:nvSpPr>
-          <p:cNvPr id="9" name="Text 7"/>
-          <p:cNvSpPr txBox="1"/>
-          <p:nvPr/>
-        </p:nvSpPr>
-        <p:spPr>
-          <a:xfrm>
-            <a:off x="457200" y="4754880"/>
-            <a:ext cx="5486400" cy="182880"/>
-          </a:xfrm>
-          <a:prstGeom prst="rect">
-            <a:avLst/>
-          </a:prstGeom>
-          <a:noFill/>
-          <a:ln/>
-        </p:spPr>
-        <p:txBody>
-          <a:bodyPr wrap="square" lIns="0" tIns="0" rIns="0" bIns="0" rtlCol="0" anchor="t"/>
-          <a:lstStyle/>
-          <a:p>
-            <a:pPr indent="0" marL="0">
-              <a:buNone/>
-            </a:pPr>
-            <a:r>
-              <a:rPr lang="en-US" sz="900" dirty="0">
-                <a:solidFill>
-                  <a:srgbClr val="998C77"/>
-                </a:solidFill>
-                <a:latin typeface="Calibri" pitchFamily="34" charset="0"/>
-                <a:ea typeface="Calibri" pitchFamily="34" charset="-122"/>
-                <a:cs typeface="Calibri" pitchFamily="34" charset="-120"/>
-              </a:rPr>
-              <a:t>Peisistratos – ein Tyrann als Wegbereiter?</a:t>
-            </a:r>
-            <a:endParaRPr lang="en-US" sz="900" dirty="0"/>
-          </a:p>
-        </p:txBody>
-      </p:sp>
-      <p:sp>
-        <p:nvSpPr>
-          <p:cNvPr id="25" name="Slide Number Placeholder 0"/>
-          <p:cNvSpPr>
-            <a:spLocks noGrp="1"/>
-          </p:cNvSpPr>
-          <p:nvPr>
-            <p:ph type="sldNum" sz="quarter" idx="4294967295"/>
-          </p:nvPr>
-        </p:nvSpPr>
-        <p:spPr>
-          <a:xfrm>
-            <a:off x="8229600" y="4727448"/>
-            <a:ext cx="457200" cy="228600"/>
-          </a:xfrm>
-          <a:prstGeom prst="rect">
-            <a:avLst/>
-          </a:prstGeom>
-          <a:extLst>
-            <a:ext uri="{C572A759-6A51-4108-AA02-DFA0A04FC94B}">
-              <ma14:wrappingTextBoxFlag xmlns:ma14="http://schemas.microsoft.com/office/mac/drawingml/2011/main" val="0"/>
-            </a:ext>
-          </a:extLst>
-        </p:spPr>
-        <p:txBody>
-          <a:bodyPr/>
-          <a:lstStyle>
-            <a:lvl1pPr>
-              <a:defRPr sz="900">
-                <a:solidFill>
-                  <a:srgbClr val="998C77"/>
-                </a:solidFill>
-                <a:latin typeface="Calibri"/>
-                <a:ea typeface="Calibri"/>
-                <a:cs typeface="Calibri"/>
-              </a:defRPr>
-            </a:lvl1pPr>
-          </a:lstStyle>
-          <a:p>
-            <a:pPr algn="r"/>
-            <a:fld id="{F7021451-1387-4CA6-816F-3879F97B5CBC}" type="slidenum">
-              <a:rPr b="0" lang="en-US"/>
-              <a:t>14</a:t>
+              <a:t>12</a:t>
             </a:fld>
             <a:endParaRPr lang="en-US"/>
           </a:p>
@@ -8276,7 +7021,7 @@
                 <a:ea typeface="Calibri" pitchFamily="34" charset="-122"/>
                 <a:cs typeface="Calibri" pitchFamily="34" charset="-120"/>
               </a:rPr>
-              <a:t>TAFEL · PUZZLE</a:t>
+              <a:t>TAFEL · BLATT TEIL B</a:t>
             </a:r>
             <a:endParaRPr lang="en-US" sz="1100" dirty="0"/>
           </a:p>
@@ -8358,7 +7103,7 @@
                 <a:ea typeface="Calibri" pitchFamily="34" charset="-122"/>
                 <a:cs typeface="Calibri" pitchFamily="34" charset="-120"/>
               </a:rPr>
-              <a:t>9 Min.</a:t>
+              <a:t>12 Min.</a:t>
             </a:r>
             <a:endParaRPr lang="en-US" sz="1100" dirty="0"/>
           </a:p>
@@ -8430,7 +7175,7 @@
               <a:buNone/>
             </a:pPr>
             <a:r>
-              <a:rPr lang="en-US" sz="1300" dirty="0">
+              <a:rPr lang="en-US" sz="1250" dirty="0">
                 <a:solidFill>
                   <a:srgbClr val="2B2318"/>
                 </a:solidFill>
@@ -8438,9 +7183,9 @@
                 <a:ea typeface="Calibri" pitchFamily="34" charset="-122"/>
                 <a:cs typeface="Calibri" pitchFamily="34" charset="-120"/>
               </a:rPr>
-              <a:t>Ein Paar nach dem anderen heftet seine Karte in das passende Feld an der Tafel.</a:t>
-            </a:r>
-            <a:endParaRPr lang="en-US" sz="1300" dirty="0"/>
+              <a:t>Ein Paar nach dem anderen heftet seine Karte ins passende Feld und sagt: „… bekommt …, weil Peisistratos … Er gewinnt dadurch …“</a:t>
+            </a:r>
+            <a:endParaRPr lang="en-US" sz="1250" dirty="0"/>
           </a:p>
         </p:txBody>
       </p:sp>
@@ -8510,7 +7255,7 @@
               <a:buNone/>
             </a:pPr>
             <a:r>
-              <a:rPr lang="en-US" sz="1300" dirty="0">
+              <a:rPr lang="en-US" sz="1250" dirty="0">
                 <a:solidFill>
                   <a:srgbClr val="2B2318"/>
                 </a:solidFill>
@@ -8518,9 +7263,9 @@
                 <a:ea typeface="Calibri" pitchFamily="34" charset="-122"/>
                 <a:cs typeface="Calibri" pitchFamily="34" charset="-120"/>
               </a:rPr>
-              <a:t>Sagt einen Satz: „… bekommt …, weil Peisistratos … Er gewinnt dadurch …“</a:t>
-            </a:r>
-            <a:endParaRPr lang="en-US" sz="1300" dirty="0"/>
+              <a:t>Alle anderen prüfen: Stimmt das Feld? Stimmt der Satz mit dem Buchtext?</a:t>
+            </a:r>
+            <a:endParaRPr lang="en-US" sz="1250" dirty="0"/>
           </a:p>
         </p:txBody>
       </p:sp>
@@ -8590,7 +7335,7 @@
               <a:buNone/>
             </a:pPr>
             <a:r>
-              <a:rPr lang="en-US" sz="1300" dirty="0">
+              <a:rPr lang="en-US" sz="1250" dirty="0">
                 <a:solidFill>
                   <a:srgbClr val="2B2318"/>
                 </a:solidFill>
@@ -8598,9 +7343,9 @@
                 <a:ea typeface="Calibri" pitchFamily="34" charset="-122"/>
                 <a:cs typeface="Calibri" pitchFamily="34" charset="-120"/>
               </a:rPr>
-              <a:t>Die anderen prüfen: Stimmt das Feld? Stimmt der Satz mit dem Buchtext?</a:t>
-            </a:r>
-            <a:endParaRPr lang="en-US" sz="1300" dirty="0"/>
+              <a:t>Alle tragen die Maßnahme als Stichwort in Teil B ins passende Feld ein.</a:t>
+            </a:r>
+            <a:endParaRPr lang="en-US" sz="1250" dirty="0"/>
           </a:p>
         </p:txBody>
       </p:sp>
@@ -8670,7 +7415,7 @@
               <a:buNone/>
             </a:pPr>
             <a:r>
-              <a:rPr lang="en-US" sz="1300" dirty="0">
+              <a:rPr lang="en-US" sz="1250" dirty="0">
                 <a:solidFill>
                   <a:srgbClr val="2B2318"/>
                 </a:solidFill>
@@ -8678,9 +7423,9 @@
                 <a:ea typeface="Calibri" pitchFamily="34" charset="-122"/>
                 <a:cs typeface="Calibri" pitchFamily="34" charset="-120"/>
               </a:rPr>
-              <a:t>Alle schauen am Ende auf das ganze Bild: Was fällt euch auf?</a:t>
-            </a:r>
-            <a:endParaRPr lang="en-US" sz="1300" dirty="0"/>
+              <a:t>Zum Schluss: Beschriftet die Pfeile und ergänzt den Merksatz.</a:t>
+            </a:r>
+            <a:endParaRPr lang="en-US" sz="1250" dirty="0"/>
           </a:p>
         </p:txBody>
       </p:sp>
@@ -8938,7 +7683,7 @@
                 <a:ea typeface="Cambria" pitchFamily="34" charset="-122"/>
                 <a:cs typeface="Cambria" pitchFamily="34" charset="-120"/>
               </a:rPr>
-              <a:t>Das ganze Bild</a:t>
+              <a:t>Vergleicht mit Teil B</a:t>
             </a:r>
             <a:endParaRPr lang="en-US" sz="2800" dirty="0"/>
           </a:p>
@@ -9003,8 +7748,8 @@
         </p:blipFill>
         <p:spPr>
           <a:xfrm>
-            <a:off x="1920240" y="1143000"/>
-            <a:ext cx="5312664" cy="3520440"/>
+            <a:off x="457200" y="1188720"/>
+            <a:ext cx="5120640" cy="3392424"/>
           </a:xfrm>
           <a:prstGeom prst="rect">
             <a:avLst/>
@@ -9013,7 +7758,170 @@
       </p:pic>
       <p:sp>
         <p:nvSpPr>
-          <p:cNvPr id="6" name="Text 3"/>
+          <p:cNvPr id="6" name="Shape 3"/>
+          <p:cNvSpPr/>
+          <p:nvPr/>
+        </p:nvSpPr>
+        <p:spPr>
+          <a:xfrm>
+            <a:off x="5806440" y="1188720"/>
+            <a:ext cx="2880360" cy="3392424"/>
+          </a:xfrm>
+          <a:prstGeom prst="roundRect">
+            <a:avLst>
+              <a:gd name="adj" fmla="val 2540"/>
+            </a:avLst>
+          </a:prstGeom>
+          <a:solidFill>
+            <a:srgbClr val="F4ECDE"/>
+          </a:solidFill>
+          <a:ln w="12700">
+            <a:solidFill>
+              <a:srgbClr val="F4ECDE"/>
+            </a:solidFill>
+            <a:prstDash val="solid"/>
+          </a:ln>
+        </p:spPr>
+      </p:sp>
+      <p:sp>
+        <p:nvSpPr>
+          <p:cNvPr id="7" name="Text 4"/>
+          <p:cNvSpPr txBox="1"/>
+          <p:nvPr/>
+        </p:nvSpPr>
+        <p:spPr>
+          <a:xfrm>
+            <a:off x="5989320" y="1280160"/>
+            <a:ext cx="2560320" cy="320040"/>
+          </a:xfrm>
+          <a:prstGeom prst="rect">
+            <a:avLst/>
+          </a:prstGeom>
+          <a:noFill/>
+          <a:ln/>
+        </p:spPr>
+        <p:txBody>
+          <a:bodyPr wrap="square" lIns="0" tIns="0" rIns="0" bIns="0" rtlCol="0" anchor="t"/>
+          <a:lstStyle/>
+          <a:p>
+            <a:pPr indent="0" marL="0">
+              <a:buNone/>
+            </a:pPr>
+            <a:r>
+              <a:rPr lang="en-US" sz="1500" b="1" dirty="0">
+                <a:solidFill>
+                  <a:srgbClr val="AD4426"/>
+                </a:solidFill>
+                <a:latin typeface="Cambria" pitchFamily="34" charset="0"/>
+                <a:ea typeface="Cambria" pitchFamily="34" charset="-122"/>
+                <a:cs typeface="Cambria" pitchFamily="34" charset="-120"/>
+              </a:rPr>
+              <a:t>Die Pfeile</a:t>
+            </a:r>
+            <a:endParaRPr lang="en-US" sz="1500" dirty="0"/>
+          </a:p>
+        </p:txBody>
+      </p:sp>
+      <p:sp>
+        <p:nvSpPr>
+          <p:cNvPr id="8" name="Text 5"/>
+          <p:cNvSpPr txBox="1"/>
+          <p:nvPr/>
+        </p:nvSpPr>
+        <p:spPr>
+          <a:xfrm>
+            <a:off x="5989320" y="1691640"/>
+            <a:ext cx="2560320" cy="2743200"/>
+          </a:xfrm>
+          <a:prstGeom prst="rect">
+            <a:avLst/>
+          </a:prstGeom>
+          <a:noFill/>
+          <a:ln/>
+        </p:spPr>
+        <p:txBody>
+          <a:bodyPr wrap="square" lIns="0" tIns="0" rIns="0" bIns="0" rtlCol="0" anchor="t"/>
+          <a:lstStyle/>
+          <a:p>
+            <a:pPr indent="0" marL="0">
+              <a:buNone/>
+            </a:pPr>
+            <a:r>
+              <a:rPr lang="en-US" sz="1300" b="1" dirty="0">
+                <a:solidFill>
+                  <a:srgbClr val="2B2318"/>
+                </a:solidFill>
+                <a:latin typeface="Calibri" pitchFamily="34" charset="0"/>
+                <a:ea typeface="Calibri" pitchFamily="34" charset="-122"/>
+                <a:cs typeface="Calibri" pitchFamily="34" charset="-120"/>
+              </a:rPr>
+              <a:t>schwarz: </a:t>
+            </a:r>
+            <a:pPr indent="0" marL="0">
+              <a:buNone/>
+            </a:pPr>
+            <a:r>
+              <a:rPr lang="en-US" sz="1300" dirty="0">
+                <a:solidFill>
+                  <a:srgbClr val="2B2318"/>
+                </a:solidFill>
+                <a:latin typeface="Calibri" pitchFamily="34" charset="0"/>
+                <a:ea typeface="Calibri" pitchFamily="34" charset="-122"/>
+                <a:cs typeface="Calibri" pitchFamily="34" charset="-120"/>
+              </a:rPr>
+              <a:t>Peisistratos fördert die Gruppen mit Maßnahmen.
+</a:t>
+            </a:r>
+            <a:pPr indent="0" marL="0">
+              <a:buNone/>
+            </a:pPr>
+            <a:r>
+              <a:rPr lang="en-US" sz="1300" b="1" dirty="0">
+                <a:solidFill>
+                  <a:srgbClr val="AA7820"/>
+                </a:solidFill>
+                <a:latin typeface="Calibri" pitchFamily="34" charset="0"/>
+                <a:ea typeface="Calibri" pitchFamily="34" charset="-122"/>
+                <a:cs typeface="Calibri" pitchFamily="34" charset="-120"/>
+              </a:rPr>
+              <a:t>gold: </a:t>
+            </a:r>
+            <a:pPr indent="0" marL="0">
+              <a:buNone/>
+            </a:pPr>
+            <a:r>
+              <a:rPr lang="en-US" sz="1300" dirty="0">
+                <a:solidFill>
+                  <a:srgbClr val="2B2318"/>
+                </a:solidFill>
+                <a:latin typeface="Calibri" pitchFamily="34" charset="0"/>
+                <a:ea typeface="Calibri" pitchFamily="34" charset="-122"/>
+                <a:cs typeface="Calibri" pitchFamily="34" charset="-120"/>
+              </a:rPr>
+              <a:t>Die Gruppen unterstützen ihn dafür.
+</a:t>
+            </a:r>
+            <a:pPr indent="0" marL="0">
+              <a:buNone/>
+            </a:pPr>
+            <a:r>
+              <a:rPr lang="en-US" sz="1300" b="1" dirty="0">
+                <a:solidFill>
+                  <a:srgbClr val="AD4426"/>
+                </a:solidFill>
+                <a:latin typeface="Calibri" pitchFamily="34" charset="0"/>
+                <a:ea typeface="Calibri" pitchFamily="34" charset="-122"/>
+                <a:cs typeface="Calibri" pitchFamily="34" charset="-120"/>
+              </a:rPr>
+              <a:t>So sichert er seine Macht.</a:t>
+            </a:r>
+            <a:endParaRPr lang="en-US" sz="1300" dirty="0"/>
+          </a:p>
+        </p:txBody>
+      </p:sp>
+      <p:sp>
+        <p:nvSpPr>
+          <p:cNvPr id="9" name="Text 6"/>
           <p:cNvSpPr txBox="1"/>
           <p:nvPr/>
         </p:nvSpPr>

</xml_diff>